<commit_message>
Clean up repo: fix .gitignore, remove duplicate binaries, fix imports, update README
</commit_message>
<xml_diff>
--- a/submission_assets/VoiceArmor_Edge_Pitch.pptx
+++ b/submission_assets/VoiceArmor_Edge_Pitch.pptx
@@ -5,18 +5,18 @@
     <p:sldMasterId id="2147483648" r:id="rId1"/>
   </p:sldMasterIdLst>
   <p:sldIdLst>
-    <p:sldId id="256" r:id="rId7"/>
-    <p:sldId id="257" r:id="rId8"/>
-    <p:sldId id="258" r:id="rId9"/>
-    <p:sldId id="259" r:id="rId10"/>
-    <p:sldId id="260" r:id="rId11"/>
-    <p:sldId id="261" r:id="rId12"/>
-    <p:sldId id="262" r:id="rId13"/>
-    <p:sldId id="263" r:id="rId14"/>
-    <p:sldId id="264" r:id="rId15"/>
-    <p:sldId id="265" r:id="rId16"/>
+    <p:sldId id="256" r:id="rId2"/>
+    <p:sldId id="257" r:id="rId3"/>
+    <p:sldId id="258" r:id="rId4"/>
+    <p:sldId id="259" r:id="rId5"/>
+    <p:sldId id="260" r:id="rId6"/>
+    <p:sldId id="261" r:id="rId7"/>
+    <p:sldId id="262" r:id="rId8"/>
+    <p:sldId id="263" r:id="rId9"/>
+    <p:sldId id="264" r:id="rId10"/>
+    <p:sldId id="265" r:id="rId11"/>
   </p:sldIdLst>
-  <p:sldSz cx="12191695" cy="6858000" type="screen4x3"/>
+  <p:sldSz cx="12192000" cy="6858000"/>
   <p:notesSz cx="6858000" cy="9144000"/>
   <p:defaultTextStyle>
     <a:defPPr>
@@ -113,6 +113,22 @@
       </a:defRPr>
     </a:lvl9pPr>
   </p:defaultTextStyle>
+  <p:extLst>
+    <p:ext uri="{EFAFB233-063F-42B5-8137-9DF3F51BA10A}">
+      <p15:sldGuideLst xmlns:p15="http://schemas.microsoft.com/office/powerpoint/2012/main">
+        <p15:guide id="1" orient="horz" pos="2160">
+          <p15:clr>
+            <a:srgbClr val="A4A3A4"/>
+          </p15:clr>
+        </p15:guide>
+        <p15:guide id="2" pos="2880">
+          <p15:clr>
+            <a:srgbClr val="A4A3A4"/>
+          </p15:clr>
+        </p15:guide>
+      </p15:sldGuideLst>
+    </p:ext>
+  </p:extLst>
 </p:presentation>
 </file>
 
@@ -154,10 +170,9 @@
           <a:lstStyle/>
           <a:p>
             <a:r>
-              <a:rPr lang="en-US" smtClean="0"/>
+              <a:rPr lang="en-US"/>
               <a:t>Click to edit Master title style</a:t>
             </a:r>
-            <a:endParaRPr lang="en-US"/>
           </a:p>
         </p:txBody>
       </p:sp>
@@ -273,10 +288,9 @@
           </a:lstStyle>
           <a:p>
             <a:r>
-              <a:rPr lang="en-US" smtClean="0"/>
+              <a:rPr lang="en-US"/>
               <a:t>Click to edit Master subtitle style</a:t>
             </a:r>
-            <a:endParaRPr lang="en-US"/>
           </a:p>
         </p:txBody>
       </p:sp>
@@ -297,7 +311,7 @@
           <a:p>
             <a:fld id="{5BCAD085-E8A6-8845-BD4E-CB4CCA059FC4}" type="datetimeFigureOut">
               <a:rPr lang="en-US" smtClean="0"/>
-              <a:t>1/27/13</a:t>
+              <a:t>9/20/2026</a:t>
             </a:fld>
             <a:endParaRPr lang="en-US"/>
           </a:p>
@@ -391,10 +405,9 @@
           <a:lstStyle/>
           <a:p>
             <a:r>
-              <a:rPr lang="en-US" smtClean="0"/>
+              <a:rPr lang="en-US"/>
               <a:t>Click to edit Master title style</a:t>
             </a:r>
-            <a:endParaRPr lang="en-US"/>
           </a:p>
         </p:txBody>
       </p:sp>
@@ -415,38 +428,37 @@
           <a:p>
             <a:pPr lvl="0"/>
             <a:r>
-              <a:rPr lang="en-US" smtClean="0"/>
+              <a:rPr lang="en-US"/>
               <a:t>Click to edit Master text styles</a:t>
             </a:r>
           </a:p>
           <a:p>
             <a:pPr lvl="1"/>
             <a:r>
-              <a:rPr lang="en-US" smtClean="0"/>
+              <a:rPr lang="en-US"/>
               <a:t>Second level</a:t>
             </a:r>
           </a:p>
           <a:p>
             <a:pPr lvl="2"/>
             <a:r>
-              <a:rPr lang="en-US" smtClean="0"/>
+              <a:rPr lang="en-US"/>
               <a:t>Third level</a:t>
             </a:r>
           </a:p>
           <a:p>
             <a:pPr lvl="3"/>
             <a:r>
-              <a:rPr lang="en-US" smtClean="0"/>
+              <a:rPr lang="en-US"/>
               <a:t>Fourth level</a:t>
             </a:r>
           </a:p>
           <a:p>
             <a:pPr lvl="4"/>
             <a:r>
-              <a:rPr lang="en-US" smtClean="0"/>
+              <a:rPr lang="en-US"/>
               <a:t>Fifth level</a:t>
             </a:r>
-            <a:endParaRPr lang="en-US"/>
           </a:p>
         </p:txBody>
       </p:sp>
@@ -467,7 +479,7 @@
           <a:p>
             <a:fld id="{5BCAD085-E8A6-8845-BD4E-CB4CCA059FC4}" type="datetimeFigureOut">
               <a:rPr lang="en-US" smtClean="0"/>
-              <a:t>1/27/13</a:t>
+              <a:t>9/20/2026</a:t>
             </a:fld>
             <a:endParaRPr lang="en-US"/>
           </a:p>
@@ -566,10 +578,9 @@
           <a:lstStyle/>
           <a:p>
             <a:r>
-              <a:rPr lang="en-US" smtClean="0"/>
+              <a:rPr lang="en-US"/>
               <a:t>Click to edit Master title style</a:t>
             </a:r>
-            <a:endParaRPr lang="en-US"/>
           </a:p>
         </p:txBody>
       </p:sp>
@@ -595,38 +606,37 @@
           <a:p>
             <a:pPr lvl="0"/>
             <a:r>
-              <a:rPr lang="en-US" smtClean="0"/>
+              <a:rPr lang="en-US"/>
               <a:t>Click to edit Master text styles</a:t>
             </a:r>
           </a:p>
           <a:p>
             <a:pPr lvl="1"/>
             <a:r>
-              <a:rPr lang="en-US" smtClean="0"/>
+              <a:rPr lang="en-US"/>
               <a:t>Second level</a:t>
             </a:r>
           </a:p>
           <a:p>
             <a:pPr lvl="2"/>
             <a:r>
-              <a:rPr lang="en-US" smtClean="0"/>
+              <a:rPr lang="en-US"/>
               <a:t>Third level</a:t>
             </a:r>
           </a:p>
           <a:p>
             <a:pPr lvl="3"/>
             <a:r>
-              <a:rPr lang="en-US" smtClean="0"/>
+              <a:rPr lang="en-US"/>
               <a:t>Fourth level</a:t>
             </a:r>
           </a:p>
           <a:p>
             <a:pPr lvl="4"/>
             <a:r>
-              <a:rPr lang="en-US" smtClean="0"/>
+              <a:rPr lang="en-US"/>
               <a:t>Fifth level</a:t>
             </a:r>
-            <a:endParaRPr lang="en-US"/>
           </a:p>
         </p:txBody>
       </p:sp>
@@ -647,7 +657,7 @@
           <a:p>
             <a:fld id="{5BCAD085-E8A6-8845-BD4E-CB4CCA059FC4}" type="datetimeFigureOut">
               <a:rPr lang="en-US" smtClean="0"/>
-              <a:t>1/27/13</a:t>
+              <a:t>9/20/2026</a:t>
             </a:fld>
             <a:endParaRPr lang="en-US"/>
           </a:p>
@@ -741,10 +751,9 @@
           <a:lstStyle/>
           <a:p>
             <a:r>
-              <a:rPr lang="en-US" smtClean="0"/>
+              <a:rPr lang="en-US"/>
               <a:t>Click to edit Master title style</a:t>
             </a:r>
-            <a:endParaRPr lang="en-US"/>
           </a:p>
         </p:txBody>
       </p:sp>
@@ -765,38 +774,37 @@
           <a:p>
             <a:pPr lvl="0"/>
             <a:r>
-              <a:rPr lang="en-US" smtClean="0"/>
+              <a:rPr lang="en-US"/>
               <a:t>Click to edit Master text styles</a:t>
             </a:r>
           </a:p>
           <a:p>
             <a:pPr lvl="1"/>
             <a:r>
-              <a:rPr lang="en-US" smtClean="0"/>
+              <a:rPr lang="en-US"/>
               <a:t>Second level</a:t>
             </a:r>
           </a:p>
           <a:p>
             <a:pPr lvl="2"/>
             <a:r>
-              <a:rPr lang="en-US" smtClean="0"/>
+              <a:rPr lang="en-US"/>
               <a:t>Third level</a:t>
             </a:r>
           </a:p>
           <a:p>
             <a:pPr lvl="3"/>
             <a:r>
-              <a:rPr lang="en-US" smtClean="0"/>
+              <a:rPr lang="en-US"/>
               <a:t>Fourth level</a:t>
             </a:r>
           </a:p>
           <a:p>
             <a:pPr lvl="4"/>
             <a:r>
-              <a:rPr lang="en-US" smtClean="0"/>
+              <a:rPr lang="en-US"/>
               <a:t>Fifth level</a:t>
             </a:r>
-            <a:endParaRPr lang="en-US"/>
           </a:p>
         </p:txBody>
       </p:sp>
@@ -817,7 +825,7 @@
           <a:p>
             <a:fld id="{5BCAD085-E8A6-8845-BD4E-CB4CCA059FC4}" type="datetimeFigureOut">
               <a:rPr lang="en-US" smtClean="0"/>
-              <a:t>1/27/13</a:t>
+              <a:t>9/20/2026</a:t>
             </a:fld>
             <a:endParaRPr lang="en-US"/>
           </a:p>
@@ -920,10 +928,9 @@
           </a:lstStyle>
           <a:p>
             <a:r>
-              <a:rPr lang="en-US" smtClean="0"/>
+              <a:rPr lang="en-US"/>
               <a:t>Click to edit Master title style</a:t>
             </a:r>
-            <a:endParaRPr lang="en-US"/>
           </a:p>
         </p:txBody>
       </p:sp>
@@ -1040,7 +1047,7 @@
           <a:p>
             <a:pPr lvl="0"/>
             <a:r>
-              <a:rPr lang="en-US" smtClean="0"/>
+              <a:rPr lang="en-US"/>
               <a:t>Click to edit Master text styles</a:t>
             </a:r>
           </a:p>
@@ -1063,7 +1070,7 @@
           <a:p>
             <a:fld id="{5BCAD085-E8A6-8845-BD4E-CB4CCA059FC4}" type="datetimeFigureOut">
               <a:rPr lang="en-US" smtClean="0"/>
-              <a:t>1/27/13</a:t>
+              <a:t>9/20/2026</a:t>
             </a:fld>
             <a:endParaRPr lang="en-US"/>
           </a:p>
@@ -1157,10 +1164,9 @@
           <a:lstStyle/>
           <a:p>
             <a:r>
-              <a:rPr lang="en-US" smtClean="0"/>
+              <a:rPr lang="en-US"/>
               <a:t>Click to edit Master title style</a:t>
             </a:r>
-            <a:endParaRPr lang="en-US"/>
           </a:p>
         </p:txBody>
       </p:sp>
@@ -1214,38 +1220,37 @@
           <a:p>
             <a:pPr lvl="0"/>
             <a:r>
-              <a:rPr lang="en-US" smtClean="0"/>
+              <a:rPr lang="en-US"/>
               <a:t>Click to edit Master text styles</a:t>
             </a:r>
           </a:p>
           <a:p>
             <a:pPr lvl="1"/>
             <a:r>
-              <a:rPr lang="en-US" smtClean="0"/>
+              <a:rPr lang="en-US"/>
               <a:t>Second level</a:t>
             </a:r>
           </a:p>
           <a:p>
             <a:pPr lvl="2"/>
             <a:r>
-              <a:rPr lang="en-US" smtClean="0"/>
+              <a:rPr lang="en-US"/>
               <a:t>Third level</a:t>
             </a:r>
           </a:p>
           <a:p>
             <a:pPr lvl="3"/>
             <a:r>
-              <a:rPr lang="en-US" smtClean="0"/>
+              <a:rPr lang="en-US"/>
               <a:t>Fourth level</a:t>
             </a:r>
           </a:p>
           <a:p>
             <a:pPr lvl="4"/>
             <a:r>
-              <a:rPr lang="en-US" smtClean="0"/>
+              <a:rPr lang="en-US"/>
               <a:t>Fifth level</a:t>
             </a:r>
-            <a:endParaRPr lang="en-US"/>
           </a:p>
         </p:txBody>
       </p:sp>
@@ -1299,38 +1304,37 @@
           <a:p>
             <a:pPr lvl="0"/>
             <a:r>
-              <a:rPr lang="en-US" smtClean="0"/>
+              <a:rPr lang="en-US"/>
               <a:t>Click to edit Master text styles</a:t>
             </a:r>
           </a:p>
           <a:p>
             <a:pPr lvl="1"/>
             <a:r>
-              <a:rPr lang="en-US" smtClean="0"/>
+              <a:rPr lang="en-US"/>
               <a:t>Second level</a:t>
             </a:r>
           </a:p>
           <a:p>
             <a:pPr lvl="2"/>
             <a:r>
-              <a:rPr lang="en-US" smtClean="0"/>
+              <a:rPr lang="en-US"/>
               <a:t>Third level</a:t>
             </a:r>
           </a:p>
           <a:p>
             <a:pPr lvl="3"/>
             <a:r>
-              <a:rPr lang="en-US" smtClean="0"/>
+              <a:rPr lang="en-US"/>
               <a:t>Fourth level</a:t>
             </a:r>
           </a:p>
           <a:p>
             <a:pPr lvl="4"/>
             <a:r>
-              <a:rPr lang="en-US" smtClean="0"/>
+              <a:rPr lang="en-US"/>
               <a:t>Fifth level</a:t>
             </a:r>
-            <a:endParaRPr lang="en-US"/>
           </a:p>
         </p:txBody>
       </p:sp>
@@ -1351,7 +1355,7 @@
           <a:p>
             <a:fld id="{5BCAD085-E8A6-8845-BD4E-CB4CCA059FC4}" type="datetimeFigureOut">
               <a:rPr lang="en-US" smtClean="0"/>
-              <a:t>1/27/13</a:t>
+              <a:t>9/20/2026</a:t>
             </a:fld>
             <a:endParaRPr lang="en-US"/>
           </a:p>
@@ -1449,10 +1453,9 @@
           </a:lstStyle>
           <a:p>
             <a:r>
-              <a:rPr lang="en-US" smtClean="0"/>
+              <a:rPr lang="en-US"/>
               <a:t>Click to edit Master title style</a:t>
             </a:r>
-            <a:endParaRPr lang="en-US"/>
           </a:p>
         </p:txBody>
       </p:sp>
@@ -1515,7 +1518,7 @@
           <a:p>
             <a:pPr lvl="0"/>
             <a:r>
-              <a:rPr lang="en-US" smtClean="0"/>
+              <a:rPr lang="en-US"/>
               <a:t>Click to edit Master text styles</a:t>
             </a:r>
           </a:p>
@@ -1571,38 +1574,37 @@
           <a:p>
             <a:pPr lvl="0"/>
             <a:r>
-              <a:rPr lang="en-US" smtClean="0"/>
+              <a:rPr lang="en-US"/>
               <a:t>Click to edit Master text styles</a:t>
             </a:r>
           </a:p>
           <a:p>
             <a:pPr lvl="1"/>
             <a:r>
-              <a:rPr lang="en-US" smtClean="0"/>
+              <a:rPr lang="en-US"/>
               <a:t>Second level</a:t>
             </a:r>
           </a:p>
           <a:p>
             <a:pPr lvl="2"/>
             <a:r>
-              <a:rPr lang="en-US" smtClean="0"/>
+              <a:rPr lang="en-US"/>
               <a:t>Third level</a:t>
             </a:r>
           </a:p>
           <a:p>
             <a:pPr lvl="3"/>
             <a:r>
-              <a:rPr lang="en-US" smtClean="0"/>
+              <a:rPr lang="en-US"/>
               <a:t>Fourth level</a:t>
             </a:r>
           </a:p>
           <a:p>
             <a:pPr lvl="4"/>
             <a:r>
-              <a:rPr lang="en-US" smtClean="0"/>
+              <a:rPr lang="en-US"/>
               <a:t>Fifth level</a:t>
             </a:r>
-            <a:endParaRPr lang="en-US"/>
           </a:p>
         </p:txBody>
       </p:sp>
@@ -1665,7 +1667,7 @@
           <a:p>
             <a:pPr lvl="0"/>
             <a:r>
-              <a:rPr lang="en-US" smtClean="0"/>
+              <a:rPr lang="en-US"/>
               <a:t>Click to edit Master text styles</a:t>
             </a:r>
           </a:p>
@@ -1721,38 +1723,37 @@
           <a:p>
             <a:pPr lvl="0"/>
             <a:r>
-              <a:rPr lang="en-US" smtClean="0"/>
+              <a:rPr lang="en-US"/>
               <a:t>Click to edit Master text styles</a:t>
             </a:r>
           </a:p>
           <a:p>
             <a:pPr lvl="1"/>
             <a:r>
-              <a:rPr lang="en-US" smtClean="0"/>
+              <a:rPr lang="en-US"/>
               <a:t>Second level</a:t>
             </a:r>
           </a:p>
           <a:p>
             <a:pPr lvl="2"/>
             <a:r>
-              <a:rPr lang="en-US" smtClean="0"/>
+              <a:rPr lang="en-US"/>
               <a:t>Third level</a:t>
             </a:r>
           </a:p>
           <a:p>
             <a:pPr lvl="3"/>
             <a:r>
-              <a:rPr lang="en-US" smtClean="0"/>
+              <a:rPr lang="en-US"/>
               <a:t>Fourth level</a:t>
             </a:r>
           </a:p>
           <a:p>
             <a:pPr lvl="4"/>
             <a:r>
-              <a:rPr lang="en-US" smtClean="0"/>
+              <a:rPr lang="en-US"/>
               <a:t>Fifth level</a:t>
             </a:r>
-            <a:endParaRPr lang="en-US"/>
           </a:p>
         </p:txBody>
       </p:sp>
@@ -1773,7 +1774,7 @@
           <a:p>
             <a:fld id="{5BCAD085-E8A6-8845-BD4E-CB4CCA059FC4}" type="datetimeFigureOut">
               <a:rPr lang="en-US" smtClean="0"/>
-              <a:t>1/27/13</a:t>
+              <a:t>9/20/2026</a:t>
             </a:fld>
             <a:endParaRPr lang="en-US"/>
           </a:p>
@@ -1867,10 +1868,9 @@
           <a:lstStyle/>
           <a:p>
             <a:r>
-              <a:rPr lang="en-US" smtClean="0"/>
+              <a:rPr lang="en-US"/>
               <a:t>Click to edit Master title style</a:t>
             </a:r>
-            <a:endParaRPr lang="en-US"/>
           </a:p>
         </p:txBody>
       </p:sp>
@@ -1891,7 +1891,7 @@
           <a:p>
             <a:fld id="{5BCAD085-E8A6-8845-BD4E-CB4CCA059FC4}" type="datetimeFigureOut">
               <a:rPr lang="en-US" smtClean="0"/>
-              <a:t>1/27/13</a:t>
+              <a:t>9/20/2026</a:t>
             </a:fld>
             <a:endParaRPr lang="en-US"/>
           </a:p>
@@ -1986,7 +1986,7 @@
           <a:p>
             <a:fld id="{5BCAD085-E8A6-8845-BD4E-CB4CCA059FC4}" type="datetimeFigureOut">
               <a:rPr lang="en-US" smtClean="0"/>
-              <a:t>1/27/13</a:t>
+              <a:t>9/20/2026</a:t>
             </a:fld>
             <a:endParaRPr lang="en-US"/>
           </a:p>
@@ -2089,10 +2089,9 @@
           </a:lstStyle>
           <a:p>
             <a:r>
-              <a:rPr lang="en-US" smtClean="0"/>
+              <a:rPr lang="en-US"/>
               <a:t>Click to edit Master title style</a:t>
             </a:r>
-            <a:endParaRPr lang="en-US"/>
           </a:p>
         </p:txBody>
       </p:sp>
@@ -2146,38 +2145,37 @@
           <a:p>
             <a:pPr lvl="0"/>
             <a:r>
-              <a:rPr lang="en-US" smtClean="0"/>
+              <a:rPr lang="en-US"/>
               <a:t>Click to edit Master text styles</a:t>
             </a:r>
           </a:p>
           <a:p>
             <a:pPr lvl="1"/>
             <a:r>
-              <a:rPr lang="en-US" smtClean="0"/>
+              <a:rPr lang="en-US"/>
               <a:t>Second level</a:t>
             </a:r>
           </a:p>
           <a:p>
             <a:pPr lvl="2"/>
             <a:r>
-              <a:rPr lang="en-US" smtClean="0"/>
+              <a:rPr lang="en-US"/>
               <a:t>Third level</a:t>
             </a:r>
           </a:p>
           <a:p>
             <a:pPr lvl="3"/>
             <a:r>
-              <a:rPr lang="en-US" smtClean="0"/>
+              <a:rPr lang="en-US"/>
               <a:t>Fourth level</a:t>
             </a:r>
           </a:p>
           <a:p>
             <a:pPr lvl="4"/>
             <a:r>
-              <a:rPr lang="en-US" smtClean="0"/>
+              <a:rPr lang="en-US"/>
               <a:t>Fifth level</a:t>
             </a:r>
-            <a:endParaRPr lang="en-US"/>
           </a:p>
         </p:txBody>
       </p:sp>
@@ -2240,7 +2238,7 @@
           <a:p>
             <a:pPr lvl="0"/>
             <a:r>
-              <a:rPr lang="en-US" smtClean="0"/>
+              <a:rPr lang="en-US"/>
               <a:t>Click to edit Master text styles</a:t>
             </a:r>
           </a:p>
@@ -2263,7 +2261,7 @@
           <a:p>
             <a:fld id="{5BCAD085-E8A6-8845-BD4E-CB4CCA059FC4}" type="datetimeFigureOut">
               <a:rPr lang="en-US" smtClean="0"/>
-              <a:t>1/27/13</a:t>
+              <a:t>9/20/2026</a:t>
             </a:fld>
             <a:endParaRPr lang="en-US"/>
           </a:p>
@@ -2366,10 +2364,9 @@
           </a:lstStyle>
           <a:p>
             <a:r>
-              <a:rPr lang="en-US" smtClean="0"/>
+              <a:rPr lang="en-US"/>
               <a:t>Click to edit Master title style</a:t>
             </a:r>
-            <a:endParaRPr lang="en-US"/>
           </a:p>
         </p:txBody>
       </p:sp>
@@ -2493,7 +2490,7 @@
           <a:p>
             <a:pPr lvl="0"/>
             <a:r>
-              <a:rPr lang="en-US" smtClean="0"/>
+              <a:rPr lang="en-US"/>
               <a:t>Click to edit Master text styles</a:t>
             </a:r>
           </a:p>
@@ -2516,7 +2513,7 @@
           <a:p>
             <a:fld id="{5BCAD085-E8A6-8845-BD4E-CB4CCA059FC4}" type="datetimeFigureOut">
               <a:rPr lang="en-US" smtClean="0"/>
-              <a:t>1/27/13</a:t>
+              <a:t>9/20/2026</a:t>
             </a:fld>
             <a:endParaRPr lang="en-US"/>
           </a:p>
@@ -2625,10 +2622,9 @@
           <a:lstStyle/>
           <a:p>
             <a:r>
-              <a:rPr lang="en-US" smtClean="0"/>
+              <a:rPr lang="en-US"/>
               <a:t>Click to edit Master title style</a:t>
             </a:r>
-            <a:endParaRPr lang="en-US"/>
           </a:p>
         </p:txBody>
       </p:sp>
@@ -2659,38 +2655,37 @@
           <a:p>
             <a:pPr lvl="0"/>
             <a:r>
-              <a:rPr lang="en-US" smtClean="0"/>
+              <a:rPr lang="en-US"/>
               <a:t>Click to edit Master text styles</a:t>
             </a:r>
           </a:p>
           <a:p>
             <a:pPr lvl="1"/>
             <a:r>
-              <a:rPr lang="en-US" smtClean="0"/>
+              <a:rPr lang="en-US"/>
               <a:t>Second level</a:t>
             </a:r>
           </a:p>
           <a:p>
             <a:pPr lvl="2"/>
             <a:r>
-              <a:rPr lang="en-US" smtClean="0"/>
+              <a:rPr lang="en-US"/>
               <a:t>Third level</a:t>
             </a:r>
           </a:p>
           <a:p>
             <a:pPr lvl="3"/>
             <a:r>
-              <a:rPr lang="en-US" smtClean="0"/>
+              <a:rPr lang="en-US"/>
               <a:t>Fourth level</a:t>
             </a:r>
           </a:p>
           <a:p>
             <a:pPr lvl="4"/>
             <a:r>
-              <a:rPr lang="en-US" smtClean="0"/>
+              <a:rPr lang="en-US"/>
               <a:t>Fifth level</a:t>
             </a:r>
-            <a:endParaRPr lang="en-US"/>
           </a:p>
         </p:txBody>
       </p:sp>
@@ -2729,7 +2724,7 @@
           <a:p>
             <a:fld id="{5BCAD085-E8A6-8845-BD4E-CB4CCA059FC4}" type="datetimeFigureOut">
               <a:rPr lang="en-US" smtClean="0"/>
-              <a:t>1/27/13</a:t>
+              <a:t>9/20/2026</a:t>
             </a:fld>
             <a:endParaRPr lang="en-US"/>
           </a:p>
@@ -3088,7 +3083,7 @@
 </file>
 
 <file path=ppt/slides/slide1.xml><?xml version="1.0" encoding="utf-8"?>
-<p:sld xmlns:a="http://schemas.openxmlformats.org/drawingml/2006/main" xmlns:p="http://schemas.openxmlformats.org/presentationml/2006/main" xmlns:r="http://schemas.openxmlformats.org/officeDocument/2006/relationships">
+<p:sld xmlns:a="http://schemas.openxmlformats.org/drawingml/2006/main" xmlns:r="http://schemas.openxmlformats.org/officeDocument/2006/relationships" xmlns:p="http://schemas.openxmlformats.org/presentationml/2006/main">
   <p:cSld>
     <p:spTree>
       <p:nvGrpSpPr>
@@ -3096,7 +3091,14 @@
         <p:cNvGrpSpPr/>
         <p:nvPr/>
       </p:nvGrpSpPr>
-      <p:grpSpPr/>
+      <p:grpSpPr>
+        <a:xfrm>
+          <a:off x="0" y="0"/>
+          <a:ext cx="0" cy="0"/>
+          <a:chOff x="0" y="0"/>
+          <a:chExt cx="0" cy="0"/>
+        </a:xfrm>
+      </p:grpSpPr>
       <p:sp>
         <p:nvSpPr>
           <p:cNvPr id="2" name="Rectangle 1"/>
@@ -3137,6 +3139,7 @@
           <a:lstStyle/>
           <a:p>
             <a:pPr algn="ctr"/>
+            <a:endParaRPr/>
           </a:p>
         </p:txBody>
       </p:sp>
@@ -3180,6 +3183,7 @@
           <a:lstStyle/>
           <a:p>
             <a:pPr algn="ctr"/>
+            <a:endParaRPr/>
           </a:p>
         </p:txBody>
       </p:sp>
@@ -3192,7 +3196,7 @@
         <p:spPr>
           <a:xfrm>
             <a:off x="1005840" y="411480"/>
-            <a:ext cx="10424160" cy="1188720"/>
+            <a:ext cx="10424160" cy="846386"/>
           </a:xfrm>
           <a:prstGeom prst="rect">
             <a:avLst/>
@@ -3205,26 +3209,34 @@
           </a:bodyPr>
           <a:lstStyle/>
           <a:p>
-            <a:pPr>
+            <a:pPr algn="just">
               <a:defRPr sz="3400" b="1">
                 <a:solidFill>
                   <a:srgbClr val="F8FAFC"/>
                 </a:solidFill>
+                <a:latin typeface="Segoe UI Semibold"/>
               </a:defRPr>
             </a:pPr>
             <a:r>
-              <a:t>VoiceArmor-Edge</a:t>
-            </a:r>
-          </a:p>
-          <a:p>
-            <a:pPr>
+              <a:rPr dirty="0" err="1"/>
+              <a:t>VoiceArmor</a:t>
+            </a:r>
+            <a:r>
+              <a:rPr dirty="0"/>
+              <a:t>-Edge</a:t>
+            </a:r>
+          </a:p>
+          <a:p>
+            <a:pPr algn="just">
               <a:defRPr sz="1500">
                 <a:solidFill>
                   <a:srgbClr val="38BDF8"/>
                 </a:solidFill>
+                <a:latin typeface="Segoe UI"/>
               </a:defRPr>
             </a:pPr>
             <a:r>
+              <a:rPr dirty="0"/>
               <a:t>Real-Time AI Voice Scam Detection on Snapdragon-Powered HP PCs</a:t>
             </a:r>
           </a:p>
@@ -3238,8 +3250,8 @@
         </p:nvSpPr>
         <p:spPr>
           <a:xfrm>
-            <a:off x="731520" y="1783080"/>
-            <a:ext cx="10698480" cy="4572000"/>
+            <a:off x="746760" y="1783080"/>
+            <a:ext cx="10698480" cy="4663440"/>
           </a:xfrm>
           <a:prstGeom prst="roundRect">
             <a:avLst/>
@@ -3272,6 +3284,7 @@
           <a:lstStyle/>
           <a:p>
             <a:pPr algn="ctr"/>
+            <a:endParaRPr/>
           </a:p>
         </p:txBody>
       </p:sp>
@@ -3284,7 +3297,7 @@
         <p:spPr>
           <a:xfrm>
             <a:off x="1051560" y="1965960"/>
-            <a:ext cx="10058400" cy="4206240"/>
+            <a:ext cx="10058400" cy="1677382"/>
           </a:xfrm>
           <a:prstGeom prst="rect">
             <a:avLst/>
@@ -3297,61 +3310,83 @@
           </a:bodyPr>
           <a:lstStyle/>
           <a:p>
-            <a:pPr>
+            <a:pPr algn="just">
               <a:spcAft>
-                <a:spcPts val="1600"/>
+                <a:spcPts val="1400"/>
               </a:spcAft>
             </a:pPr>
             <a:r>
-              <a:rPr sz="1800" b="1">
+              <a:rPr sz="1700" b="1" dirty="0">
                 <a:solidFill>
                   <a:srgbClr val="F8FAFC"/>
                 </a:solidFill>
+                <a:latin typeface="Segoe UI Semibold"/>
               </a:rPr>
               <a:t>Participant: Bharath G Devadiga (ECE Department)</a:t>
             </a:r>
           </a:p>
           <a:p>
-            <a:pPr>
+            <a:pPr algn="just">
               <a:spcAft>
-                <a:spcPts val="1600"/>
+                <a:spcPts val="1400"/>
               </a:spcAft>
             </a:pPr>
             <a:r>
-              <a:rPr sz="1800" b="1">
+              <a:rPr sz="1700" b="1" dirty="0">
                 <a:solidFill>
                   <a:srgbClr val="F8FAFC"/>
                 </a:solidFill>
+                <a:latin typeface="Segoe UI Semibold"/>
               </a:rPr>
               <a:t>College Email: bharath.23ec014@sode-edu.in</a:t>
             </a:r>
           </a:p>
           <a:p>
-            <a:pPr>
+            <a:pPr algn="just">
               <a:spcAft>
-                <a:spcPts val="1600"/>
+                <a:spcPts val="1400"/>
               </a:spcAft>
             </a:pPr>
             <a:r>
-              <a:rPr sz="1800" b="1">
+              <a:rPr sz="1700" b="1" dirty="0">
                 <a:solidFill>
                   <a:srgbClr val="F8FAFC"/>
                 </a:solidFill>
-              </a:rPr>
-              <a:t>Target Hardware: Snapdragon X HP OmniBook + Arduino UNO Q</a:t>
-            </a:r>
-          </a:p>
-          <a:p>
-            <a:pPr>
+                <a:latin typeface="Segoe UI Semibold"/>
+              </a:rPr>
+              <a:t>Target Hardware: Snapdragon X HP </a:t>
+            </a:r>
+            <a:r>
+              <a:rPr sz="1700" b="1" dirty="0" err="1">
+                <a:solidFill>
+                  <a:srgbClr val="F8FAFC"/>
+                </a:solidFill>
+                <a:latin typeface="Segoe UI Semibold"/>
+              </a:rPr>
+              <a:t>OmniBook</a:t>
+            </a:r>
+            <a:r>
+              <a:rPr sz="1700" b="1" dirty="0">
+                <a:solidFill>
+                  <a:srgbClr val="F8FAFC"/>
+                </a:solidFill>
+                <a:latin typeface="Segoe UI Semibold"/>
+              </a:rPr>
+              <a:t> + Arduino UNO Q</a:t>
+            </a:r>
+          </a:p>
+          <a:p>
+            <a:pPr algn="just">
               <a:spcAft>
-                <a:spcPts val="1600"/>
+                <a:spcPts val="1400"/>
               </a:spcAft>
             </a:pPr>
             <a:r>
-              <a:rPr sz="1800" b="1">
+              <a:rPr sz="1700" b="1" dirty="0">
                 <a:solidFill>
                   <a:srgbClr val="F8FAFC"/>
                 </a:solidFill>
+                <a:latin typeface="Segoe UI Semibold"/>
               </a:rPr>
               <a:t>Competition: Snapdragon AI Lab Build &amp; Present Challenge 2026</a:t>
             </a:r>
@@ -3367,7 +3402,7 @@
 </file>
 
 <file path=ppt/slides/slide10.xml><?xml version="1.0" encoding="utf-8"?>
-<p:sld xmlns:a="http://schemas.openxmlformats.org/drawingml/2006/main" xmlns:p="http://schemas.openxmlformats.org/presentationml/2006/main" xmlns:r="http://schemas.openxmlformats.org/officeDocument/2006/relationships">
+<p:sld xmlns:a="http://schemas.openxmlformats.org/drawingml/2006/main" xmlns:r="http://schemas.openxmlformats.org/officeDocument/2006/relationships" xmlns:p="http://schemas.openxmlformats.org/presentationml/2006/main">
   <p:cSld>
     <p:spTree>
       <p:nvGrpSpPr>
@@ -3375,7 +3410,14 @@
         <p:cNvGrpSpPr/>
         <p:nvPr/>
       </p:nvGrpSpPr>
-      <p:grpSpPr/>
+      <p:grpSpPr>
+        <a:xfrm>
+          <a:off x="0" y="0"/>
+          <a:ext cx="0" cy="0"/>
+          <a:chOff x="0" y="0"/>
+          <a:chExt cx="0" cy="0"/>
+        </a:xfrm>
+      </p:grpSpPr>
       <p:sp>
         <p:nvSpPr>
           <p:cNvPr id="2" name="Rectangle 1"/>
@@ -3416,6 +3458,7 @@
           <a:lstStyle/>
           <a:p>
             <a:pPr algn="ctr"/>
+            <a:endParaRPr/>
           </a:p>
         </p:txBody>
       </p:sp>
@@ -3459,6 +3502,7 @@
           <a:lstStyle/>
           <a:p>
             <a:pPr algn="ctr"/>
+            <a:endParaRPr/>
           </a:p>
         </p:txBody>
       </p:sp>
@@ -3471,7 +3515,7 @@
         <p:spPr>
           <a:xfrm>
             <a:off x="1005840" y="411480"/>
-            <a:ext cx="10424160" cy="1188720"/>
+            <a:ext cx="10424160" cy="754053"/>
           </a:xfrm>
           <a:prstGeom prst="rect">
             <a:avLst/>
@@ -3484,27 +3528,39 @@
           </a:bodyPr>
           <a:lstStyle/>
           <a:p>
-            <a:pPr>
+            <a:pPr algn="just">
               <a:defRPr sz="2800" b="1">
                 <a:solidFill>
                   <a:srgbClr val="F8FAFC"/>
                 </a:solidFill>
+                <a:latin typeface="Segoe UI Semibold"/>
               </a:defRPr>
             </a:pPr>
             <a:r>
+              <a:rPr dirty="0"/>
               <a:t>Future Plans &amp; Summary</a:t>
             </a:r>
           </a:p>
           <a:p>
-            <a:pPr>
+            <a:pPr algn="just">
               <a:defRPr sz="1500">
                 <a:solidFill>
                   <a:srgbClr val="38BDF8"/>
                 </a:solidFill>
+                <a:latin typeface="Segoe UI"/>
               </a:defRPr>
             </a:pPr>
             <a:r>
-              <a:t>Next steps to improve VoiceArmor-Edge</a:t>
+              <a:rPr dirty="0"/>
+              <a:t>Next steps to improve </a:t>
+            </a:r>
+            <a:r>
+              <a:rPr dirty="0" err="1"/>
+              <a:t>VoiceArmor</a:t>
+            </a:r>
+            <a:r>
+              <a:rPr dirty="0"/>
+              <a:t>-Edge</a:t>
             </a:r>
           </a:p>
         </p:txBody>
@@ -3518,7 +3574,7 @@
         <p:spPr>
           <a:xfrm>
             <a:off x="731520" y="1783080"/>
-            <a:ext cx="10698480" cy="4572000"/>
+            <a:ext cx="10698480" cy="4663440"/>
           </a:xfrm>
           <a:prstGeom prst="roundRect">
             <a:avLst/>
@@ -3551,6 +3607,7 @@
           <a:lstStyle/>
           <a:p>
             <a:pPr algn="ctr"/>
+            <a:endParaRPr/>
           </a:p>
         </p:txBody>
       </p:sp>
@@ -3563,7 +3620,7 @@
         <p:spPr>
           <a:xfrm>
             <a:off x="1051560" y="1965960"/>
-            <a:ext cx="10058400" cy="4206240"/>
+            <a:ext cx="10058400" cy="2544286"/>
           </a:xfrm>
           <a:prstGeom prst="rect">
             <a:avLst/>
@@ -3576,95 +3633,141 @@
           </a:bodyPr>
           <a:lstStyle/>
           <a:p>
-            <a:pPr>
+            <a:pPr marL="285750" indent="-285750" algn="just">
+              <a:lnSpc>
+                <a:spcPct val="150000"/>
+              </a:lnSpc>
               <a:spcAft>
-                <a:spcPts val="1600"/>
+                <a:spcPts val="1400"/>
               </a:spcAft>
+              <a:buFont typeface="Wingdings" panose="05000000000000000000" pitchFamily="2" charset="2"/>
+              <a:buChar char="Ø"/>
             </a:pPr>
             <a:r>
-              <a:rPr b="1" sz="1700">
+              <a:rPr sz="1700" b="1" dirty="0">
                 <a:solidFill>
                   <a:srgbClr val="F8FAFC"/>
                 </a:solidFill>
-              </a:rPr>
-              <a:t>•  Indian Languages: </a:t>
-            </a:r>
-            <a:r>
-              <a:rPr b="0" sz="1600">
-                <a:solidFill>
-                  <a:srgbClr val="CBD5E1"/>
-                </a:solidFill>
+                <a:latin typeface="Segoe UI" panose="020B0502040204020203" pitchFamily="34" charset="0"/>
+                <a:cs typeface="Segoe UI" panose="020B0502040204020203" pitchFamily="34" charset="0"/>
+              </a:rPr>
+              <a:t>Indian Languages: </a:t>
+            </a:r>
+            <a:r>
+              <a:rPr sz="1700" b="0" dirty="0">
+                <a:solidFill>
+                  <a:srgbClr val="E2E8F0"/>
+                </a:solidFill>
+                <a:latin typeface="Segoe UI" panose="020B0502040204020203" pitchFamily="34" charset="0"/>
+                <a:cs typeface="Segoe UI" panose="020B0502040204020203" pitchFamily="34" charset="0"/>
               </a:rPr>
               <a:t>Train on more regional Indian accents and dialects for even higher accuracy.</a:t>
             </a:r>
           </a:p>
           <a:p>
-            <a:pPr>
+            <a:pPr marL="285750" indent="-285750" algn="just">
+              <a:lnSpc>
+                <a:spcPct val="150000"/>
+              </a:lnSpc>
               <a:spcAft>
-                <a:spcPts val="1600"/>
+                <a:spcPts val="1400"/>
               </a:spcAft>
+              <a:buFont typeface="Wingdings" panose="05000000000000000000" pitchFamily="2" charset="2"/>
+              <a:buChar char="Ø"/>
             </a:pPr>
             <a:r>
-              <a:rPr b="1" sz="1700">
+              <a:rPr sz="1700" b="1" dirty="0">
                 <a:solidFill>
                   <a:srgbClr val="F8FAFC"/>
                 </a:solidFill>
-              </a:rPr>
-              <a:t>•  Smart Call Detection: </a:t>
-            </a:r>
-            <a:r>
-              <a:rPr b="0" sz="1600">
-                <a:solidFill>
-                  <a:srgbClr val="CBD5E1"/>
-                </a:solidFill>
+                <a:latin typeface="Segoe UI" panose="020B0502040204020203" pitchFamily="34" charset="0"/>
+                <a:cs typeface="Segoe UI" panose="020B0502040204020203" pitchFamily="34" charset="0"/>
+              </a:rPr>
+              <a:t>Smart Call Detection: </a:t>
+            </a:r>
+            <a:r>
+              <a:rPr sz="1700" b="0" dirty="0">
+                <a:solidFill>
+                  <a:srgbClr val="E2E8F0"/>
+                </a:solidFill>
+                <a:latin typeface="Segoe UI" panose="020B0502040204020203" pitchFamily="34" charset="0"/>
+                <a:cs typeface="Segoe UI" panose="020B0502040204020203" pitchFamily="34" charset="0"/>
               </a:rPr>
               <a:t>Automatically wake up only when a call starts to save even more power.</a:t>
             </a:r>
           </a:p>
           <a:p>
-            <a:pPr>
+            <a:pPr marL="285750" indent="-285750" algn="just">
+              <a:lnSpc>
+                <a:spcPct val="150000"/>
+              </a:lnSpc>
               <a:spcAft>
-                <a:spcPts val="1600"/>
+                <a:spcPts val="1400"/>
               </a:spcAft>
+              <a:buFont typeface="Wingdings" panose="05000000000000000000" pitchFamily="2" charset="2"/>
+              <a:buChar char="Ø"/>
             </a:pPr>
             <a:r>
-              <a:rPr b="1" sz="1700">
+              <a:rPr sz="1700" b="1" dirty="0">
                 <a:solidFill>
                   <a:srgbClr val="F8FAFC"/>
                 </a:solidFill>
-              </a:rPr>
-              <a:t>•  Browser Plugin: </a:t>
-            </a:r>
-            <a:r>
-              <a:rPr b="0" sz="1600">
-                <a:solidFill>
-                  <a:srgbClr val="CBD5E1"/>
-                </a:solidFill>
+                <a:latin typeface="Segoe UI" panose="020B0502040204020203" pitchFamily="34" charset="0"/>
+                <a:cs typeface="Segoe UI" panose="020B0502040204020203" pitchFamily="34" charset="0"/>
+              </a:rPr>
+              <a:t>Browser Plugin: </a:t>
+            </a:r>
+            <a:r>
+              <a:rPr sz="1700" b="0" dirty="0">
+                <a:solidFill>
+                  <a:srgbClr val="E2E8F0"/>
+                </a:solidFill>
+                <a:latin typeface="Segoe UI" panose="020B0502040204020203" pitchFamily="34" charset="0"/>
+                <a:cs typeface="Segoe UI" panose="020B0502040204020203" pitchFamily="34" charset="0"/>
               </a:rPr>
               <a:t>Show quick warning banners inside web meeting apps like Google Meet.</a:t>
             </a:r>
           </a:p>
           <a:p>
-            <a:pPr>
+            <a:pPr marL="285750" indent="-285750" algn="just">
+              <a:lnSpc>
+                <a:spcPct val="150000"/>
+              </a:lnSpc>
               <a:spcAft>
-                <a:spcPts val="1600"/>
+                <a:spcPts val="1400"/>
               </a:spcAft>
+              <a:buFont typeface="Wingdings" panose="05000000000000000000" pitchFamily="2" charset="2"/>
+              <a:buChar char="Ø"/>
             </a:pPr>
             <a:r>
-              <a:rPr b="1" sz="1700">
+              <a:rPr sz="1700" b="1" dirty="0">
                 <a:solidFill>
                   <a:srgbClr val="F8FAFC"/>
                 </a:solidFill>
-              </a:rPr>
-              <a:t>•  Summary: </a:t>
-            </a:r>
-            <a:r>
-              <a:rPr b="0" sz="1600">
-                <a:solidFill>
-                  <a:srgbClr val="CBD5E1"/>
-                </a:solidFill>
-              </a:rPr>
-              <a:t>VoiceArmor-Edge shows how Snapdragon PCs can protect everyday people from AI scams locally and privately.</a:t>
+                <a:latin typeface="Segoe UI" panose="020B0502040204020203" pitchFamily="34" charset="0"/>
+                <a:cs typeface="Segoe UI" panose="020B0502040204020203" pitchFamily="34" charset="0"/>
+              </a:rPr>
+              <a:t>Summary: </a:t>
+            </a:r>
+            <a:r>
+              <a:rPr sz="1700" b="0" dirty="0" err="1">
+                <a:solidFill>
+                  <a:srgbClr val="E2E8F0"/>
+                </a:solidFill>
+                <a:latin typeface="Segoe UI" panose="020B0502040204020203" pitchFamily="34" charset="0"/>
+                <a:cs typeface="Segoe UI" panose="020B0502040204020203" pitchFamily="34" charset="0"/>
+              </a:rPr>
+              <a:t>VoiceArmor</a:t>
+            </a:r>
+            <a:r>
+              <a:rPr sz="1700" b="0" dirty="0">
+                <a:solidFill>
+                  <a:srgbClr val="E2E8F0"/>
+                </a:solidFill>
+                <a:latin typeface="Segoe UI" panose="020B0502040204020203" pitchFamily="34" charset="0"/>
+                <a:cs typeface="Segoe UI" panose="020B0502040204020203" pitchFamily="34" charset="0"/>
+              </a:rPr>
+              <a:t>-Edge shows how Snapdragon PCs can protect everyday people from AI scams locally and privately.</a:t>
             </a:r>
           </a:p>
         </p:txBody>
@@ -3678,7 +3781,7 @@
 </file>
 
 <file path=ppt/slides/slide2.xml><?xml version="1.0" encoding="utf-8"?>
-<p:sld xmlns:a="http://schemas.openxmlformats.org/drawingml/2006/main" xmlns:p="http://schemas.openxmlformats.org/presentationml/2006/main" xmlns:r="http://schemas.openxmlformats.org/officeDocument/2006/relationships">
+<p:sld xmlns:a="http://schemas.openxmlformats.org/drawingml/2006/main" xmlns:r="http://schemas.openxmlformats.org/officeDocument/2006/relationships" xmlns:p="http://schemas.openxmlformats.org/presentationml/2006/main">
   <p:cSld>
     <p:spTree>
       <p:nvGrpSpPr>
@@ -3686,7 +3789,14 @@
         <p:cNvGrpSpPr/>
         <p:nvPr/>
       </p:nvGrpSpPr>
-      <p:grpSpPr/>
+      <p:grpSpPr>
+        <a:xfrm>
+          <a:off x="0" y="0"/>
+          <a:ext cx="0" cy="0"/>
+          <a:chOff x="0" y="0"/>
+          <a:chExt cx="0" cy="0"/>
+        </a:xfrm>
+      </p:grpSpPr>
       <p:sp>
         <p:nvSpPr>
           <p:cNvPr id="2" name="Rectangle 1"/>
@@ -3727,6 +3837,7 @@
           <a:lstStyle/>
           <a:p>
             <a:pPr algn="ctr"/>
+            <a:endParaRPr/>
           </a:p>
         </p:txBody>
       </p:sp>
@@ -3770,6 +3881,7 @@
           <a:lstStyle/>
           <a:p>
             <a:pPr algn="ctr"/>
+            <a:endParaRPr/>
           </a:p>
         </p:txBody>
       </p:sp>
@@ -3800,6 +3912,7 @@
                 <a:solidFill>
                   <a:srgbClr val="F8FAFC"/>
                 </a:solidFill>
+                <a:latin typeface="Segoe UI Semibold"/>
               </a:defRPr>
             </a:pPr>
             <a:r>
@@ -3812,6 +3925,7 @@
                 <a:solidFill>
                   <a:srgbClr val="38BDF8"/>
                 </a:solidFill>
+                <a:latin typeface="Segoe UI"/>
               </a:defRPr>
             </a:pPr>
             <a:r>
@@ -3829,7 +3943,7 @@
         <p:spPr>
           <a:xfrm>
             <a:off x="731520" y="1783080"/>
-            <a:ext cx="10698480" cy="4572000"/>
+            <a:ext cx="10698480" cy="4663440"/>
           </a:xfrm>
           <a:prstGeom prst="roundRect">
             <a:avLst/>
@@ -3862,6 +3976,7 @@
           <a:lstStyle/>
           <a:p>
             <a:pPr algn="ctr"/>
+            <a:endParaRPr/>
           </a:p>
         </p:txBody>
       </p:sp>
@@ -3874,7 +3989,7 @@
         <p:spPr>
           <a:xfrm>
             <a:off x="1051560" y="1965960"/>
-            <a:ext cx="10058400" cy="4206240"/>
+            <a:ext cx="10058400" cy="3721532"/>
           </a:xfrm>
           <a:prstGeom prst="rect">
             <a:avLst/>
@@ -3887,93 +4002,129 @@
           </a:bodyPr>
           <a:lstStyle/>
           <a:p>
-            <a:pPr>
+            <a:pPr marL="285750" indent="-285750" algn="just">
+              <a:lnSpc>
+                <a:spcPct val="150000"/>
+              </a:lnSpc>
               <a:spcAft>
-                <a:spcPts val="1600"/>
+                <a:spcPts val="1400"/>
               </a:spcAft>
+              <a:buFont typeface="Wingdings" panose="05000000000000000000" pitchFamily="2" charset="2"/>
+              <a:buChar char="Ø"/>
             </a:pPr>
             <a:r>
-              <a:rPr b="1" sz="1700">
+              <a:rPr sz="1700" b="1" dirty="0">
                 <a:solidFill>
                   <a:srgbClr val="F8FAFC"/>
                 </a:solidFill>
-              </a:rPr>
-              <a:t>•  Voice Cloning Scams: </a:t>
-            </a:r>
-            <a:r>
-              <a:rPr b="0" sz="1600">
-                <a:solidFill>
-                  <a:srgbClr val="CBD5E1"/>
-                </a:solidFill>
+                <a:latin typeface="Segoe UI" panose="020B0502040204020203" pitchFamily="34" charset="0"/>
+                <a:cs typeface="Segoe UI" panose="020B0502040204020203" pitchFamily="34" charset="0"/>
+              </a:rPr>
+              <a:t>Voice Cloning Scams: </a:t>
+            </a:r>
+            <a:r>
+              <a:rPr sz="1700" b="0" dirty="0">
+                <a:solidFill>
+                  <a:srgbClr val="E2E8F0"/>
+                </a:solidFill>
+                <a:latin typeface="Segoe UI" panose="020B0502040204020203" pitchFamily="34" charset="0"/>
+                <a:cs typeface="Segoe UI" panose="020B0502040204020203" pitchFamily="34" charset="0"/>
               </a:rPr>
               <a:t>Scammers use AI tools to clone voices of police officers, family members, or managers to steal money (such as recent Digital Arrest scams in India).</a:t>
             </a:r>
           </a:p>
           <a:p>
-            <a:pPr>
+            <a:pPr marL="285750" indent="-285750" algn="just">
+              <a:lnSpc>
+                <a:spcPct val="150000"/>
+              </a:lnSpc>
               <a:spcAft>
-                <a:spcPts val="1600"/>
+                <a:spcPts val="1400"/>
               </a:spcAft>
+              <a:buFont typeface="Wingdings" panose="05000000000000000000" pitchFamily="2" charset="2"/>
+              <a:buChar char="Ø"/>
             </a:pPr>
             <a:r>
-              <a:rPr b="1" sz="1700">
+              <a:rPr sz="1700" b="1" dirty="0">
                 <a:solidFill>
                   <a:srgbClr val="F8FAFC"/>
                 </a:solidFill>
-              </a:rPr>
-              <a:t>•  No Protection on PC: </a:t>
-            </a:r>
-            <a:r>
-              <a:rPr b="0" sz="1600">
-                <a:solidFill>
-                  <a:srgbClr val="CBD5E1"/>
-                </a:solidFill>
+                <a:latin typeface="Segoe UI" panose="020B0502040204020203" pitchFamily="34" charset="0"/>
+                <a:cs typeface="Segoe UI" panose="020B0502040204020203" pitchFamily="34" charset="0"/>
+              </a:rPr>
+              <a:t>No Protection on PC: </a:t>
+            </a:r>
+            <a:r>
+              <a:rPr sz="1700" b="0" dirty="0">
+                <a:solidFill>
+                  <a:srgbClr val="E2E8F0"/>
+                </a:solidFill>
+                <a:latin typeface="Segoe UI" panose="020B0502040204020203" pitchFamily="34" charset="0"/>
+                <a:cs typeface="Segoe UI" panose="020B0502040204020203" pitchFamily="34" charset="0"/>
               </a:rPr>
               <a:t>Meeting apps like Microsoft Teams, Zoom, and WhatsApp cannot tell if an incoming voice is real or AI-generated.</a:t>
             </a:r>
           </a:p>
           <a:p>
-            <a:pPr>
+            <a:pPr marL="285750" indent="-285750" algn="just">
+              <a:lnSpc>
+                <a:spcPct val="150000"/>
+              </a:lnSpc>
               <a:spcAft>
-                <a:spcPts val="1600"/>
+                <a:spcPts val="1400"/>
               </a:spcAft>
+              <a:buFont typeface="Wingdings" panose="05000000000000000000" pitchFamily="2" charset="2"/>
+              <a:buChar char="Ø"/>
             </a:pPr>
             <a:r>
-              <a:rPr b="1" sz="1700">
+              <a:rPr sz="1700" b="1" dirty="0">
                 <a:solidFill>
                   <a:srgbClr val="F8FAFC"/>
                 </a:solidFill>
-              </a:rPr>
-              <a:t>•  Why Cloud Checks Fail: </a:t>
-            </a:r>
-            <a:r>
-              <a:rPr b="0" sz="1600">
-                <a:solidFill>
-                  <a:srgbClr val="CBD5E1"/>
-                </a:solidFill>
+                <a:latin typeface="Segoe UI" panose="020B0502040204020203" pitchFamily="34" charset="0"/>
+                <a:cs typeface="Segoe UI" panose="020B0502040204020203" pitchFamily="34" charset="0"/>
+              </a:rPr>
+              <a:t>Why Cloud Checks Fail: </a:t>
+            </a:r>
+            <a:r>
+              <a:rPr sz="1700" b="0" dirty="0">
+                <a:solidFill>
+                  <a:srgbClr val="E2E8F0"/>
+                </a:solidFill>
+                <a:latin typeface="Segoe UI" panose="020B0502040204020203" pitchFamily="34" charset="0"/>
+                <a:cs typeface="Segoe UI" panose="020B0502040204020203" pitchFamily="34" charset="0"/>
               </a:rPr>
               <a:t>Sending live call audio to a cloud server is too slow, needs constant internet, and leaks private conversations.</a:t>
             </a:r>
           </a:p>
           <a:p>
-            <a:pPr>
+            <a:pPr marL="285750" indent="-285750" algn="just">
+              <a:lnSpc>
+                <a:spcPct val="150000"/>
+              </a:lnSpc>
               <a:spcAft>
-                <a:spcPts val="1600"/>
+                <a:spcPts val="1400"/>
               </a:spcAft>
+              <a:buFont typeface="Wingdings" panose="05000000000000000000" pitchFamily="2" charset="2"/>
+              <a:buChar char="Ø"/>
             </a:pPr>
             <a:r>
-              <a:rPr b="1" sz="1700">
+              <a:rPr sz="1700" b="1" dirty="0">
                 <a:solidFill>
                   <a:srgbClr val="F8FAFC"/>
                 </a:solidFill>
-              </a:rPr>
-              <a:t>•  What We Need: </a:t>
-            </a:r>
-            <a:r>
-              <a:rPr b="0" sz="1600">
-                <a:solidFill>
-                  <a:srgbClr val="CBD5E1"/>
-                </a:solidFill>
+                <a:latin typeface="Segoe UI" panose="020B0502040204020203" pitchFamily="34" charset="0"/>
+                <a:cs typeface="Segoe UI" panose="020B0502040204020203" pitchFamily="34" charset="0"/>
+              </a:rPr>
+              <a:t>What We Need: </a:t>
+            </a:r>
+            <a:r>
+              <a:rPr sz="1700" b="0" dirty="0">
+                <a:solidFill>
+                  <a:srgbClr val="E2E8F0"/>
+                </a:solidFill>
+                <a:latin typeface="Segoe UI" panose="020B0502040204020203" pitchFamily="34" charset="0"/>
+                <a:cs typeface="Segoe UI" panose="020B0502040204020203" pitchFamily="34" charset="0"/>
               </a:rPr>
               <a:t>A fast, private tool running directly on the laptop that checks the audio locally and warns the user right away.</a:t>
             </a:r>
@@ -3989,7 +4140,7 @@
 </file>
 
 <file path=ppt/slides/slide3.xml><?xml version="1.0" encoding="utf-8"?>
-<p:sld xmlns:a="http://schemas.openxmlformats.org/drawingml/2006/main" xmlns:p="http://schemas.openxmlformats.org/presentationml/2006/main" xmlns:r="http://schemas.openxmlformats.org/officeDocument/2006/relationships">
+<p:sld xmlns:a="http://schemas.openxmlformats.org/drawingml/2006/main" xmlns:r="http://schemas.openxmlformats.org/officeDocument/2006/relationships" xmlns:p="http://schemas.openxmlformats.org/presentationml/2006/main">
   <p:cSld>
     <p:spTree>
       <p:nvGrpSpPr>
@@ -3997,7 +4148,14 @@
         <p:cNvGrpSpPr/>
         <p:nvPr/>
       </p:nvGrpSpPr>
-      <p:grpSpPr/>
+      <p:grpSpPr>
+        <a:xfrm>
+          <a:off x="0" y="0"/>
+          <a:ext cx="0" cy="0"/>
+          <a:chOff x="0" y="0"/>
+          <a:chExt cx="0" cy="0"/>
+        </a:xfrm>
+      </p:grpSpPr>
       <p:sp>
         <p:nvSpPr>
           <p:cNvPr id="2" name="Rectangle 1"/>
@@ -4038,6 +4196,7 @@
           <a:lstStyle/>
           <a:p>
             <a:pPr algn="ctr"/>
+            <a:endParaRPr/>
           </a:p>
         </p:txBody>
       </p:sp>
@@ -4081,6 +4240,7 @@
           <a:lstStyle/>
           <a:p>
             <a:pPr algn="ctr"/>
+            <a:endParaRPr/>
           </a:p>
         </p:txBody>
       </p:sp>
@@ -4093,7 +4253,7 @@
         <p:spPr>
           <a:xfrm>
             <a:off x="1005840" y="411480"/>
-            <a:ext cx="10424160" cy="1188720"/>
+            <a:ext cx="10424160" cy="754053"/>
           </a:xfrm>
           <a:prstGeom prst="rect">
             <a:avLst/>
@@ -4106,26 +4266,30 @@
           </a:bodyPr>
           <a:lstStyle/>
           <a:p>
-            <a:pPr>
+            <a:pPr algn="just">
               <a:defRPr sz="2800" b="1">
                 <a:solidFill>
                   <a:srgbClr val="F8FAFC"/>
                 </a:solidFill>
+                <a:latin typeface="Segoe UI Semibold"/>
               </a:defRPr>
             </a:pPr>
             <a:r>
+              <a:rPr dirty="0"/>
               <a:t>Why Use the Snapdragon Hexagon NPU?</a:t>
             </a:r>
           </a:p>
           <a:p>
-            <a:pPr>
+            <a:pPr algn="just">
               <a:defRPr sz="1500">
                 <a:solidFill>
                   <a:srgbClr val="38BDF8"/>
                 </a:solidFill>
+                <a:latin typeface="Segoe UI"/>
               </a:defRPr>
             </a:pPr>
             <a:r>
+              <a:rPr dirty="0"/>
               <a:t>Fast, private detection without slowing down your PC</a:t>
             </a:r>
           </a:p>
@@ -4140,7 +4304,7 @@
         <p:spPr>
           <a:xfrm>
             <a:off x="731520" y="1783080"/>
-            <a:ext cx="10698480" cy="4572000"/>
+            <a:ext cx="10698480" cy="4663440"/>
           </a:xfrm>
           <a:prstGeom prst="roundRect">
             <a:avLst/>
@@ -4173,6 +4337,7 @@
           <a:lstStyle/>
           <a:p>
             <a:pPr algn="ctr"/>
+            <a:endParaRPr/>
           </a:p>
         </p:txBody>
       </p:sp>
@@ -4185,7 +4350,7 @@
         <p:spPr>
           <a:xfrm>
             <a:off x="1051560" y="1965960"/>
-            <a:ext cx="10058400" cy="4206240"/>
+            <a:ext cx="10058400" cy="3721532"/>
           </a:xfrm>
           <a:prstGeom prst="rect">
             <a:avLst/>
@@ -4198,93 +4363,129 @@
           </a:bodyPr>
           <a:lstStyle/>
           <a:p>
-            <a:pPr>
+            <a:pPr marL="285750" indent="-285750" algn="just">
+              <a:lnSpc>
+                <a:spcPct val="150000"/>
+              </a:lnSpc>
               <a:spcAft>
-                <a:spcPts val="1600"/>
+                <a:spcPts val="1400"/>
               </a:spcAft>
+              <a:buFont typeface="Wingdings" panose="05000000000000000000" pitchFamily="2" charset="2"/>
+              <a:buChar char="Ø"/>
             </a:pPr>
             <a:r>
-              <a:rPr b="1" sz="1700">
+              <a:rPr sz="1700" b="1" dirty="0">
                 <a:solidFill>
                   <a:srgbClr val="F8FAFC"/>
                 </a:solidFill>
-              </a:rPr>
-              <a:t>•  Instant Warnings: </a:t>
-            </a:r>
-            <a:r>
-              <a:rPr b="0" sz="1600">
-                <a:solidFill>
-                  <a:srgbClr val="CBD5E1"/>
-                </a:solidFill>
+                <a:latin typeface="Segoe UI" panose="020B0502040204020203" pitchFamily="34" charset="0"/>
+                <a:cs typeface="Segoe UI" panose="020B0502040204020203" pitchFamily="34" charset="0"/>
+              </a:rPr>
+              <a:t>Instant Warnings: </a:t>
+            </a:r>
+            <a:r>
+              <a:rPr sz="1700" b="0" dirty="0">
+                <a:solidFill>
+                  <a:srgbClr val="E2E8F0"/>
+                </a:solidFill>
+                <a:latin typeface="Segoe UI" panose="020B0502040204020203" pitchFamily="34" charset="0"/>
+                <a:cs typeface="Segoe UI" panose="020B0502040204020203" pitchFamily="34" charset="0"/>
               </a:rPr>
               <a:t>The Hexagon NPU checks voice patterns in under 15ms, warning you while the call is still happening.</a:t>
             </a:r>
           </a:p>
           <a:p>
-            <a:pPr>
+            <a:pPr marL="285750" indent="-285750" algn="just">
+              <a:lnSpc>
+                <a:spcPct val="150000"/>
+              </a:lnSpc>
               <a:spcAft>
-                <a:spcPts val="1600"/>
+                <a:spcPts val="1400"/>
               </a:spcAft>
+              <a:buFont typeface="Wingdings" panose="05000000000000000000" pitchFamily="2" charset="2"/>
+              <a:buChar char="Ø"/>
             </a:pPr>
             <a:r>
-              <a:rPr b="1" sz="1700">
+              <a:rPr sz="1700" b="1" dirty="0">
                 <a:solidFill>
                   <a:srgbClr val="F8FAFC"/>
                 </a:solidFill>
-              </a:rPr>
-              <a:t>•  100% Private: </a:t>
-            </a:r>
-            <a:r>
-              <a:rPr b="0" sz="1600">
-                <a:solidFill>
-                  <a:srgbClr val="CBD5E1"/>
-                </a:solidFill>
+                <a:latin typeface="Segoe UI" panose="020B0502040204020203" pitchFamily="34" charset="0"/>
+                <a:cs typeface="Segoe UI" panose="020B0502040204020203" pitchFamily="34" charset="0"/>
+              </a:rPr>
+              <a:t>100% Private: </a:t>
+            </a:r>
+            <a:r>
+              <a:rPr sz="1700" b="0" dirty="0">
+                <a:solidFill>
+                  <a:srgbClr val="E2E8F0"/>
+                </a:solidFill>
+                <a:latin typeface="Segoe UI" panose="020B0502040204020203" pitchFamily="34" charset="0"/>
+                <a:cs typeface="Segoe UI" panose="020B0502040204020203" pitchFamily="34" charset="0"/>
               </a:rPr>
               <a:t>Audio stays on your laptop. Zero data goes to the internet, and it works completely in Airplane Mode.</a:t>
             </a:r>
           </a:p>
           <a:p>
-            <a:pPr>
+            <a:pPr marL="285750" indent="-285750" algn="just">
+              <a:lnSpc>
+                <a:spcPct val="150000"/>
+              </a:lnSpc>
               <a:spcAft>
-                <a:spcPts val="1600"/>
+                <a:spcPts val="1400"/>
               </a:spcAft>
+              <a:buFont typeface="Wingdings" panose="05000000000000000000" pitchFamily="2" charset="2"/>
+              <a:buChar char="Ø"/>
             </a:pPr>
             <a:r>
-              <a:rPr b="1" sz="1700">
+              <a:rPr sz="1700" b="1" dirty="0">
                 <a:solidFill>
                   <a:srgbClr val="F8FAFC"/>
                 </a:solidFill>
-              </a:rPr>
-              <a:t>•  Smooth Laptop Performance: </a:t>
-            </a:r>
-            <a:r>
-              <a:rPr b="0" sz="1600">
-                <a:solidFill>
-                  <a:srgbClr val="CBD5E1"/>
-                </a:solidFill>
+                <a:latin typeface="Segoe UI" panose="020B0502040204020203" pitchFamily="34" charset="0"/>
+                <a:cs typeface="Segoe UI" panose="020B0502040204020203" pitchFamily="34" charset="0"/>
+              </a:rPr>
+              <a:t>Smooth Laptop Performance: </a:t>
+            </a:r>
+            <a:r>
+              <a:rPr sz="1700" b="0" dirty="0">
+                <a:solidFill>
+                  <a:srgbClr val="E2E8F0"/>
+                </a:solidFill>
+                <a:latin typeface="Segoe UI" panose="020B0502040204020203" pitchFamily="34" charset="0"/>
+                <a:cs typeface="Segoe UI" panose="020B0502040204020203" pitchFamily="34" charset="0"/>
               </a:rPr>
               <a:t>The NPU handles the AI math in the background, leaving the CPU and GPU free for your video call.</a:t>
             </a:r>
           </a:p>
           <a:p>
-            <a:pPr>
+            <a:pPr marL="285750" indent="-285750" algn="just">
+              <a:lnSpc>
+                <a:spcPct val="150000"/>
+              </a:lnSpc>
               <a:spcAft>
-                <a:spcPts val="1600"/>
+                <a:spcPts val="1400"/>
               </a:spcAft>
+              <a:buFont typeface="Wingdings" panose="05000000000000000000" pitchFamily="2" charset="2"/>
+              <a:buChar char="Ø"/>
             </a:pPr>
             <a:r>
-              <a:rPr b="1" sz="1700">
+              <a:rPr sz="1700" b="1" dirty="0">
                 <a:solidFill>
                   <a:srgbClr val="F8FAFC"/>
                 </a:solidFill>
-              </a:rPr>
-              <a:t>•  Saves Battery: </a:t>
-            </a:r>
-            <a:r>
-              <a:rPr b="0" sz="1600">
-                <a:solidFill>
-                  <a:srgbClr val="CBD5E1"/>
-                </a:solidFill>
+                <a:latin typeface="Segoe UI" panose="020B0502040204020203" pitchFamily="34" charset="0"/>
+                <a:cs typeface="Segoe UI" panose="020B0502040204020203" pitchFamily="34" charset="0"/>
+              </a:rPr>
+              <a:t>Saves Battery: </a:t>
+            </a:r>
+            <a:r>
+              <a:rPr sz="1700" b="0" dirty="0">
+                <a:solidFill>
+                  <a:srgbClr val="E2E8F0"/>
+                </a:solidFill>
+                <a:latin typeface="Segoe UI" panose="020B0502040204020203" pitchFamily="34" charset="0"/>
+                <a:cs typeface="Segoe UI" panose="020B0502040204020203" pitchFamily="34" charset="0"/>
               </a:rPr>
               <a:t>The NPU runs efficiently at low power, so you can keep protection turned on all day without draining the battery.</a:t>
             </a:r>
@@ -4300,7 +4501,7 @@
 </file>
 
 <file path=ppt/slides/slide4.xml><?xml version="1.0" encoding="utf-8"?>
-<p:sld xmlns:a="http://schemas.openxmlformats.org/drawingml/2006/main" xmlns:p="http://schemas.openxmlformats.org/presentationml/2006/main" xmlns:r="http://schemas.openxmlformats.org/officeDocument/2006/relationships">
+<p:sld xmlns:a="http://schemas.openxmlformats.org/drawingml/2006/main" xmlns:r="http://schemas.openxmlformats.org/officeDocument/2006/relationships" xmlns:p="http://schemas.openxmlformats.org/presentationml/2006/main">
   <p:cSld>
     <p:spTree>
       <p:nvGrpSpPr>
@@ -4308,7 +4509,14 @@
         <p:cNvGrpSpPr/>
         <p:nvPr/>
       </p:nvGrpSpPr>
-      <p:grpSpPr/>
+      <p:grpSpPr>
+        <a:xfrm>
+          <a:off x="0" y="0"/>
+          <a:ext cx="0" cy="0"/>
+          <a:chOff x="0" y="0"/>
+          <a:chExt cx="0" cy="0"/>
+        </a:xfrm>
+      </p:grpSpPr>
       <p:sp>
         <p:nvSpPr>
           <p:cNvPr id="2" name="Rectangle 1"/>
@@ -4349,6 +4557,7 @@
           <a:lstStyle/>
           <a:p>
             <a:pPr algn="ctr"/>
+            <a:endParaRPr/>
           </a:p>
         </p:txBody>
       </p:sp>
@@ -4392,6 +4601,7 @@
           <a:lstStyle/>
           <a:p>
             <a:pPr algn="ctr"/>
+            <a:endParaRPr/>
           </a:p>
         </p:txBody>
       </p:sp>
@@ -4404,7 +4614,7 @@
         <p:spPr>
           <a:xfrm>
             <a:off x="1005840" y="411480"/>
-            <a:ext cx="10424160" cy="1188720"/>
+            <a:ext cx="10424160" cy="754053"/>
           </a:xfrm>
           <a:prstGeom prst="rect">
             <a:avLst/>
@@ -4417,26 +4627,30 @@
           </a:bodyPr>
           <a:lstStyle/>
           <a:p>
-            <a:pPr>
+            <a:pPr algn="just">
               <a:defRPr sz="2800" b="1">
                 <a:solidFill>
                   <a:srgbClr val="F8FAFC"/>
                 </a:solidFill>
+                <a:latin typeface="Segoe UI Semibold"/>
               </a:defRPr>
             </a:pPr>
             <a:r>
+              <a:rPr dirty="0"/>
               <a:t>How It Works: Audio Processing</a:t>
             </a:r>
           </a:p>
           <a:p>
-            <a:pPr>
+            <a:pPr algn="just">
               <a:defRPr sz="1500">
                 <a:solidFill>
                   <a:srgbClr val="38BDF8"/>
                 </a:solidFill>
+                <a:latin typeface="Segoe UI"/>
               </a:defRPr>
             </a:pPr>
             <a:r>
+              <a:rPr dirty="0"/>
               <a:t>Turning incoming sound into voice frequency pictures</a:t>
             </a:r>
           </a:p>
@@ -4451,7 +4665,7 @@
         <p:spPr>
           <a:xfrm>
             <a:off x="731520" y="1783080"/>
-            <a:ext cx="10698480" cy="4572000"/>
+            <a:ext cx="10698480" cy="4663440"/>
           </a:xfrm>
           <a:prstGeom prst="roundRect">
             <a:avLst/>
@@ -4484,6 +4698,7 @@
           <a:lstStyle/>
           <a:p>
             <a:pPr algn="ctr"/>
+            <a:endParaRPr/>
           </a:p>
         </p:txBody>
       </p:sp>
@@ -4496,7 +4711,7 @@
         <p:spPr>
           <a:xfrm>
             <a:off x="1051560" y="1965960"/>
-            <a:ext cx="10058400" cy="4206240"/>
+            <a:ext cx="10058400" cy="3329116"/>
           </a:xfrm>
           <a:prstGeom prst="rect">
             <a:avLst/>
@@ -4509,93 +4724,129 @@
           </a:bodyPr>
           <a:lstStyle/>
           <a:p>
-            <a:pPr>
+            <a:pPr marL="285750" indent="-285750" algn="just">
+              <a:lnSpc>
+                <a:spcPct val="150000"/>
+              </a:lnSpc>
               <a:spcAft>
-                <a:spcPts val="1600"/>
+                <a:spcPts val="1400"/>
               </a:spcAft>
+              <a:buFont typeface="Wingdings" panose="05000000000000000000" pitchFamily="2" charset="2"/>
+              <a:buChar char="Ø"/>
             </a:pPr>
             <a:r>
-              <a:rPr b="1" sz="1700">
+              <a:rPr sz="1700" b="1" dirty="0">
                 <a:solidFill>
                   <a:srgbClr val="F8FAFC"/>
                 </a:solidFill>
-              </a:rPr>
-              <a:t>•  Listen in Small Chunks: </a:t>
-            </a:r>
-            <a:r>
-              <a:rPr b="0" sz="1600">
-                <a:solidFill>
-                  <a:srgbClr val="CBD5E1"/>
-                </a:solidFill>
+                <a:latin typeface="Segoe UI" panose="020B0502040204020203" pitchFamily="34" charset="0"/>
+                <a:cs typeface="Segoe UI" panose="020B0502040204020203" pitchFamily="34" charset="0"/>
+              </a:rPr>
+              <a:t>Listen in Small Chunks: </a:t>
+            </a:r>
+            <a:r>
+              <a:rPr sz="1700" b="0" dirty="0">
+                <a:solidFill>
+                  <a:srgbClr val="E2E8F0"/>
+                </a:solidFill>
+                <a:latin typeface="Segoe UI" panose="020B0502040204020203" pitchFamily="34" charset="0"/>
+                <a:cs typeface="Segoe UI" panose="020B0502040204020203" pitchFamily="34" charset="0"/>
               </a:rPr>
               <a:t>Takes 250ms slices of incoming call sound from your speakers or headset.</a:t>
             </a:r>
           </a:p>
           <a:p>
-            <a:pPr>
+            <a:pPr marL="285750" indent="-285750" algn="just">
+              <a:lnSpc>
+                <a:spcPct val="150000"/>
+              </a:lnSpc>
               <a:spcAft>
-                <a:spcPts val="1600"/>
+                <a:spcPts val="1400"/>
               </a:spcAft>
+              <a:buFont typeface="Wingdings" panose="05000000000000000000" pitchFamily="2" charset="2"/>
+              <a:buChar char="Ø"/>
             </a:pPr>
             <a:r>
-              <a:rPr b="1" sz="1700">
+              <a:rPr sz="1700" b="1" dirty="0">
                 <a:solidFill>
                   <a:srgbClr val="F8FAFC"/>
                 </a:solidFill>
-              </a:rPr>
-              <a:t>•  Generate Spectrograms: </a:t>
-            </a:r>
-            <a:r>
-              <a:rPr b="0" sz="1600">
-                <a:solidFill>
-                  <a:srgbClr val="CBD5E1"/>
-                </a:solidFill>
+                <a:latin typeface="Segoe UI" panose="020B0502040204020203" pitchFamily="34" charset="0"/>
+                <a:cs typeface="Segoe UI" panose="020B0502040204020203" pitchFamily="34" charset="0"/>
+              </a:rPr>
+              <a:t>Generate Spectrograms: </a:t>
+            </a:r>
+            <a:r>
+              <a:rPr sz="1700" b="0" dirty="0">
+                <a:solidFill>
+                  <a:srgbClr val="E2E8F0"/>
+                </a:solidFill>
+                <a:latin typeface="Segoe UI" panose="020B0502040204020203" pitchFamily="34" charset="0"/>
+                <a:cs typeface="Segoe UI" panose="020B0502040204020203" pitchFamily="34" charset="0"/>
               </a:rPr>
               <a:t>Converts raw sound waves into frequency pictures (called Mel-Spectrograms) showing sound energy over time.</a:t>
             </a:r>
           </a:p>
           <a:p>
-            <a:pPr>
+            <a:pPr marL="285750" indent="-285750" algn="just">
+              <a:lnSpc>
+                <a:spcPct val="150000"/>
+              </a:lnSpc>
               <a:spcAft>
-                <a:spcPts val="1600"/>
+                <a:spcPts val="1400"/>
               </a:spcAft>
+              <a:buFont typeface="Wingdings" panose="05000000000000000000" pitchFamily="2" charset="2"/>
+              <a:buChar char="Ø"/>
             </a:pPr>
             <a:r>
-              <a:rPr b="1" sz="1700">
+              <a:rPr sz="1700" b="1" dirty="0">
                 <a:solidFill>
                   <a:srgbClr val="F8FAFC"/>
                 </a:solidFill>
-              </a:rPr>
-              <a:t>•  Finding Fake Voice Clues: </a:t>
-            </a:r>
-            <a:r>
-              <a:rPr b="0" sz="1600">
-                <a:solidFill>
-                  <a:srgbClr val="CBD5E1"/>
-                </a:solidFill>
+                <a:latin typeface="Segoe UI" panose="020B0502040204020203" pitchFamily="34" charset="0"/>
+                <a:cs typeface="Segoe UI" panose="020B0502040204020203" pitchFamily="34" charset="0"/>
+              </a:rPr>
+              <a:t>Finding Fake Voice Clues: </a:t>
+            </a:r>
+            <a:r>
+              <a:rPr sz="1700" b="0" dirty="0">
+                <a:solidFill>
+                  <a:srgbClr val="E2E8F0"/>
+                </a:solidFill>
+                <a:latin typeface="Segoe UI" panose="020B0502040204020203" pitchFamily="34" charset="0"/>
+                <a:cs typeface="Segoe UI" panose="020B0502040204020203" pitchFamily="34" charset="0"/>
               </a:rPr>
               <a:t>AI voice cloning tools leave subtle artifacts in high frequencies that natural human voices do not have.</a:t>
             </a:r>
           </a:p>
           <a:p>
-            <a:pPr>
+            <a:pPr marL="285750" indent="-285750" algn="just">
+              <a:lnSpc>
+                <a:spcPct val="150000"/>
+              </a:lnSpc>
               <a:spcAft>
-                <a:spcPts val="1600"/>
+                <a:spcPts val="1400"/>
               </a:spcAft>
+              <a:buFont typeface="Wingdings" panose="05000000000000000000" pitchFamily="2" charset="2"/>
+              <a:buChar char="Ø"/>
             </a:pPr>
             <a:r>
-              <a:rPr b="1" sz="1700">
+              <a:rPr sz="1700" b="1" dirty="0">
                 <a:solidFill>
                   <a:srgbClr val="F8FAFC"/>
                 </a:solidFill>
-              </a:rPr>
-              <a:t>•  Fast &amp; Lightweight: </a:t>
-            </a:r>
-            <a:r>
-              <a:rPr b="0" sz="1600">
-                <a:solidFill>
-                  <a:srgbClr val="CBD5E1"/>
-                </a:solidFill>
+                <a:latin typeface="Segoe UI" panose="020B0502040204020203" pitchFamily="34" charset="0"/>
+                <a:cs typeface="Segoe UI" panose="020B0502040204020203" pitchFamily="34" charset="0"/>
+              </a:rPr>
+              <a:t>Fast &amp; Lightweight: </a:t>
+            </a:r>
+            <a:r>
+              <a:rPr sz="1700" b="0" dirty="0">
+                <a:solidFill>
+                  <a:srgbClr val="E2E8F0"/>
+                </a:solidFill>
+                <a:latin typeface="Segoe UI" panose="020B0502040204020203" pitchFamily="34" charset="0"/>
+                <a:cs typeface="Segoe UI" panose="020B0502040204020203" pitchFamily="34" charset="0"/>
               </a:rPr>
               <a:t>Sound features are prepared quickly on the CPU and passed directly to the NPU.</a:t>
             </a:r>
@@ -4611,7 +4862,7 @@
 </file>
 
 <file path=ppt/slides/slide5.xml><?xml version="1.0" encoding="utf-8"?>
-<p:sld xmlns:a="http://schemas.openxmlformats.org/drawingml/2006/main" xmlns:p="http://schemas.openxmlformats.org/presentationml/2006/main" xmlns:r="http://schemas.openxmlformats.org/officeDocument/2006/relationships">
+<p:sld xmlns:a="http://schemas.openxmlformats.org/drawingml/2006/main" xmlns:r="http://schemas.openxmlformats.org/officeDocument/2006/relationships" xmlns:p="http://schemas.openxmlformats.org/presentationml/2006/main">
   <p:cSld>
     <p:spTree>
       <p:nvGrpSpPr>
@@ -4619,7 +4870,14 @@
         <p:cNvGrpSpPr/>
         <p:nvPr/>
       </p:nvGrpSpPr>
-      <p:grpSpPr/>
+      <p:grpSpPr>
+        <a:xfrm>
+          <a:off x="0" y="0"/>
+          <a:ext cx="0" cy="0"/>
+          <a:chOff x="0" y="0"/>
+          <a:chExt cx="0" cy="0"/>
+        </a:xfrm>
+      </p:grpSpPr>
       <p:sp>
         <p:nvSpPr>
           <p:cNvPr id="2" name="Rectangle 1"/>
@@ -4660,6 +4918,7 @@
           <a:lstStyle/>
           <a:p>
             <a:pPr algn="ctr"/>
+            <a:endParaRPr/>
           </a:p>
         </p:txBody>
       </p:sp>
@@ -4703,6 +4962,7 @@
           <a:lstStyle/>
           <a:p>
             <a:pPr algn="ctr"/>
+            <a:endParaRPr/>
           </a:p>
         </p:txBody>
       </p:sp>
@@ -4715,7 +4975,7 @@
         <p:spPr>
           <a:xfrm>
             <a:off x="1005840" y="411480"/>
-            <a:ext cx="10424160" cy="1188720"/>
+            <a:ext cx="10424160" cy="754053"/>
           </a:xfrm>
           <a:prstGeom prst="rect">
             <a:avLst/>
@@ -4728,26 +4988,30 @@
           </a:bodyPr>
           <a:lstStyle/>
           <a:p>
-            <a:pPr>
+            <a:pPr algn="just">
               <a:defRPr sz="2800" b="1">
                 <a:solidFill>
                   <a:srgbClr val="F8FAFC"/>
                 </a:solidFill>
+                <a:latin typeface="Segoe UI Semibold"/>
               </a:defRPr>
             </a:pPr>
             <a:r>
+              <a:rPr dirty="0"/>
               <a:t>The AI Model &amp; Qualcomm AI Hub</a:t>
             </a:r>
           </a:p>
           <a:p>
-            <a:pPr>
+            <a:pPr algn="just">
               <a:defRPr sz="1500">
                 <a:solidFill>
                   <a:srgbClr val="38BDF8"/>
                 </a:solidFill>
+                <a:latin typeface="Segoe UI"/>
               </a:defRPr>
             </a:pPr>
             <a:r>
+              <a:rPr dirty="0"/>
               <a:t>Using lightweight, optimized models from Qualcomm's catalog</a:t>
             </a:r>
           </a:p>
@@ -4762,7 +5026,7 @@
         <p:spPr>
           <a:xfrm>
             <a:off x="731520" y="1783080"/>
-            <a:ext cx="10698480" cy="4572000"/>
+            <a:ext cx="10698480" cy="4663440"/>
           </a:xfrm>
           <a:prstGeom prst="roundRect">
             <a:avLst/>
@@ -4795,6 +5059,7 @@
           <a:lstStyle/>
           <a:p>
             <a:pPr algn="ctr"/>
+            <a:endParaRPr/>
           </a:p>
         </p:txBody>
       </p:sp>
@@ -4807,7 +5072,7 @@
         <p:spPr>
           <a:xfrm>
             <a:off x="1051560" y="1965960"/>
-            <a:ext cx="10058400" cy="4206240"/>
+            <a:ext cx="10058400" cy="3721532"/>
           </a:xfrm>
           <a:prstGeom prst="rect">
             <a:avLst/>
@@ -4820,93 +5085,129 @@
           </a:bodyPr>
           <a:lstStyle/>
           <a:p>
-            <a:pPr>
+            <a:pPr marL="285750" indent="-285750" algn="just">
+              <a:lnSpc>
+                <a:spcPct val="150000"/>
+              </a:lnSpc>
               <a:spcAft>
-                <a:spcPts val="1600"/>
+                <a:spcPts val="1400"/>
               </a:spcAft>
+              <a:buFont typeface="Wingdings" panose="05000000000000000000" pitchFamily="2" charset="2"/>
+              <a:buChar char="Ø"/>
             </a:pPr>
             <a:r>
-              <a:rPr b="1" sz="1700">
+              <a:rPr sz="1700" b="1" dirty="0">
                 <a:solidFill>
                   <a:srgbClr val="F8FAFC"/>
                 </a:solidFill>
-              </a:rPr>
-              <a:t>•  Proven Audio Model: </a:t>
-            </a:r>
-            <a:r>
-              <a:rPr b="0" sz="1600">
-                <a:solidFill>
-                  <a:srgbClr val="CBD5E1"/>
-                </a:solidFill>
+                <a:latin typeface="Segoe UI" panose="020B0502040204020203" pitchFamily="34" charset="0"/>
+                <a:cs typeface="Segoe UI" panose="020B0502040204020203" pitchFamily="34" charset="0"/>
+              </a:rPr>
+              <a:t>Proven Audio Model: </a:t>
+            </a:r>
+            <a:r>
+              <a:rPr sz="1700" b="0" dirty="0">
+                <a:solidFill>
+                  <a:srgbClr val="E2E8F0"/>
+                </a:solidFill>
+                <a:latin typeface="Segoe UI" panose="020B0502040204020203" pitchFamily="34" charset="0"/>
+                <a:cs typeface="Segoe UI" panose="020B0502040204020203" pitchFamily="34" charset="0"/>
               </a:rPr>
               <a:t>Built using compact audio classification models from the Qualcomm AI Hub library.</a:t>
             </a:r>
           </a:p>
           <a:p>
-            <a:pPr>
+            <a:pPr marL="285750" indent="-285750" algn="just">
+              <a:lnSpc>
+                <a:spcPct val="150000"/>
+              </a:lnSpc>
               <a:spcAft>
-                <a:spcPts val="1600"/>
+                <a:spcPts val="1400"/>
               </a:spcAft>
+              <a:buFont typeface="Wingdings" panose="05000000000000000000" pitchFamily="2" charset="2"/>
+              <a:buChar char="Ø"/>
             </a:pPr>
             <a:r>
-              <a:rPr b="1" sz="1700">
+              <a:rPr sz="1700" b="1" dirty="0">
                 <a:solidFill>
                   <a:srgbClr val="F8FAFC"/>
                 </a:solidFill>
-              </a:rPr>
-              <a:t>•  INT8 Quantization: </a:t>
-            </a:r>
-            <a:r>
-              <a:rPr b="0" sz="1600">
-                <a:solidFill>
-                  <a:srgbClr val="CBD5E1"/>
-                </a:solidFill>
+                <a:latin typeface="Segoe UI" panose="020B0502040204020203" pitchFamily="34" charset="0"/>
+                <a:cs typeface="Segoe UI" panose="020B0502040204020203" pitchFamily="34" charset="0"/>
+              </a:rPr>
+              <a:t>INT8 Quantization: </a:t>
+            </a:r>
+            <a:r>
+              <a:rPr sz="1700" b="0" dirty="0">
+                <a:solidFill>
+                  <a:srgbClr val="E2E8F0"/>
+                </a:solidFill>
+                <a:latin typeface="Segoe UI" panose="020B0502040204020203" pitchFamily="34" charset="0"/>
+                <a:cs typeface="Segoe UI" panose="020B0502040204020203" pitchFamily="34" charset="0"/>
               </a:rPr>
               <a:t>Converts model numbers to 8-bit integers so it runs fast on the Hexagon NPU and uses very little memory.</a:t>
             </a:r>
           </a:p>
           <a:p>
-            <a:pPr>
+            <a:pPr marL="285750" indent="-285750" algn="just">
+              <a:lnSpc>
+                <a:spcPct val="150000"/>
+              </a:lnSpc>
               <a:spcAft>
-                <a:spcPts val="1600"/>
+                <a:spcPts val="1400"/>
               </a:spcAft>
+              <a:buFont typeface="Wingdings" panose="05000000000000000000" pitchFamily="2" charset="2"/>
+              <a:buChar char="Ø"/>
             </a:pPr>
             <a:r>
-              <a:rPr b="1" sz="1700">
+              <a:rPr sz="1700" b="1" dirty="0">
                 <a:solidFill>
                   <a:srgbClr val="F8FAFC"/>
                 </a:solidFill>
-              </a:rPr>
-              <a:t>•  Qualcomm AI Hub Tools: </a:t>
-            </a:r>
-            <a:r>
-              <a:rPr b="0" sz="1600">
-                <a:solidFill>
-                  <a:srgbClr val="CBD5E1"/>
-                </a:solidFill>
+                <a:latin typeface="Segoe UI" panose="020B0502040204020203" pitchFamily="34" charset="0"/>
+                <a:cs typeface="Segoe UI" panose="020B0502040204020203" pitchFamily="34" charset="0"/>
+              </a:rPr>
+              <a:t>Qualcomm AI Hub Tools: </a:t>
+            </a:r>
+            <a:r>
+              <a:rPr sz="1700" b="0" dirty="0">
+                <a:solidFill>
+                  <a:srgbClr val="E2E8F0"/>
+                </a:solidFill>
+                <a:latin typeface="Segoe UI" panose="020B0502040204020203" pitchFamily="34" charset="0"/>
+                <a:cs typeface="Segoe UI" panose="020B0502040204020203" pitchFamily="34" charset="0"/>
               </a:rPr>
               <a:t>Compiled using Qualcomm's official tools specifically for Snapdragon X chips.</a:t>
             </a:r>
           </a:p>
           <a:p>
-            <a:pPr>
+            <a:pPr marL="285750" indent="-285750" algn="just">
+              <a:lnSpc>
+                <a:spcPct val="150000"/>
+              </a:lnSpc>
               <a:spcAft>
-                <a:spcPts val="1600"/>
+                <a:spcPts val="1400"/>
               </a:spcAft>
+              <a:buFont typeface="Wingdings" panose="05000000000000000000" pitchFamily="2" charset="2"/>
+              <a:buChar char="Ø"/>
             </a:pPr>
             <a:r>
-              <a:rPr b="1" sz="1700">
+              <a:rPr sz="1700" b="1" dirty="0">
                 <a:solidFill>
                   <a:srgbClr val="F8FAFC"/>
                 </a:solidFill>
-              </a:rPr>
-              <a:t>•  Direct NPU Format: </a:t>
-            </a:r>
-            <a:r>
-              <a:rPr b="0" sz="1600">
-                <a:solidFill>
-                  <a:srgbClr val="CBD5E1"/>
-                </a:solidFill>
+                <a:latin typeface="Segoe UI" panose="020B0502040204020203" pitchFamily="34" charset="0"/>
+                <a:cs typeface="Segoe UI" panose="020B0502040204020203" pitchFamily="34" charset="0"/>
+              </a:rPr>
+              <a:t>Direct NPU Format: </a:t>
+            </a:r>
+            <a:r>
+              <a:rPr sz="1700" b="0" dirty="0">
+                <a:solidFill>
+                  <a:srgbClr val="E2E8F0"/>
+                </a:solidFill>
+                <a:latin typeface="Segoe UI" panose="020B0502040204020203" pitchFamily="34" charset="0"/>
+                <a:cs typeface="Segoe UI" panose="020B0502040204020203" pitchFamily="34" charset="0"/>
               </a:rPr>
               <a:t>Exported as an ONNX model that runs directly on Qualcomm's hardware accelerator.</a:t>
             </a:r>
@@ -4922,7 +5223,7 @@
 </file>
 
 <file path=ppt/slides/slide6.xml><?xml version="1.0" encoding="utf-8"?>
-<p:sld xmlns:a="http://schemas.openxmlformats.org/drawingml/2006/main" xmlns:p="http://schemas.openxmlformats.org/presentationml/2006/main" xmlns:r="http://schemas.openxmlformats.org/officeDocument/2006/relationships">
+<p:sld xmlns:a="http://schemas.openxmlformats.org/drawingml/2006/main" xmlns:r="http://schemas.openxmlformats.org/officeDocument/2006/relationships" xmlns:p="http://schemas.openxmlformats.org/presentationml/2006/main">
   <p:cSld>
     <p:spTree>
       <p:nvGrpSpPr>
@@ -4930,7 +5231,14 @@
         <p:cNvGrpSpPr/>
         <p:nvPr/>
       </p:nvGrpSpPr>
-      <p:grpSpPr/>
+      <p:grpSpPr>
+        <a:xfrm>
+          <a:off x="0" y="0"/>
+          <a:ext cx="0" cy="0"/>
+          <a:chOff x="0" y="0"/>
+          <a:chExt cx="0" cy="0"/>
+        </a:xfrm>
+      </p:grpSpPr>
       <p:sp>
         <p:nvSpPr>
           <p:cNvPr id="2" name="Rectangle 1"/>
@@ -4971,6 +5279,7 @@
           <a:lstStyle/>
           <a:p>
             <a:pPr algn="ctr"/>
+            <a:endParaRPr/>
           </a:p>
         </p:txBody>
       </p:sp>
@@ -5014,6 +5323,7 @@
           <a:lstStyle/>
           <a:p>
             <a:pPr algn="ctr"/>
+            <a:endParaRPr/>
           </a:p>
         </p:txBody>
       </p:sp>
@@ -5026,7 +5336,7 @@
         <p:spPr>
           <a:xfrm>
             <a:off x="1005840" y="411480"/>
-            <a:ext cx="10424160" cy="1188720"/>
+            <a:ext cx="10424160" cy="754053"/>
           </a:xfrm>
           <a:prstGeom prst="rect">
             <a:avLst/>
@@ -5039,26 +5349,30 @@
           </a:bodyPr>
           <a:lstStyle/>
           <a:p>
-            <a:pPr>
+            <a:pPr algn="just">
               <a:defRPr sz="2800" b="1">
                 <a:solidFill>
                   <a:srgbClr val="F8FAFC"/>
                 </a:solidFill>
+                <a:latin typeface="Segoe UI Semibold"/>
               </a:defRPr>
             </a:pPr>
             <a:r>
+              <a:rPr dirty="0"/>
               <a:t>Software Setup on Windows</a:t>
             </a:r>
           </a:p>
           <a:p>
-            <a:pPr>
+            <a:pPr algn="just">
               <a:defRPr sz="1500">
                 <a:solidFill>
                   <a:srgbClr val="38BDF8"/>
                 </a:solidFill>
+                <a:latin typeface="Segoe UI"/>
               </a:defRPr>
             </a:pPr>
             <a:r>
+              <a:rPr dirty="0"/>
               <a:t>Clean, direct pipeline on Windows on Snapdragon</a:t>
             </a:r>
           </a:p>
@@ -5073,7 +5387,7 @@
         <p:spPr>
           <a:xfrm>
             <a:off x="731520" y="1783080"/>
-            <a:ext cx="10698480" cy="4572000"/>
+            <a:ext cx="10698480" cy="4663440"/>
           </a:xfrm>
           <a:prstGeom prst="roundRect">
             <a:avLst/>
@@ -5106,6 +5420,7 @@
           <a:lstStyle/>
           <a:p>
             <a:pPr algn="ctr"/>
+            <a:endParaRPr/>
           </a:p>
         </p:txBody>
       </p:sp>
@@ -5118,7 +5433,7 @@
         <p:spPr>
           <a:xfrm>
             <a:off x="1051560" y="1965960"/>
-            <a:ext cx="10058400" cy="4206240"/>
+            <a:ext cx="10058400" cy="2544286"/>
           </a:xfrm>
           <a:prstGeom prst="rect">
             <a:avLst/>
@@ -5131,93 +5446,129 @@
           </a:bodyPr>
           <a:lstStyle/>
           <a:p>
-            <a:pPr>
+            <a:pPr marL="285750" indent="-285750" algn="just">
+              <a:lnSpc>
+                <a:spcPct val="150000"/>
+              </a:lnSpc>
               <a:spcAft>
-                <a:spcPts val="1600"/>
+                <a:spcPts val="1400"/>
               </a:spcAft>
+              <a:buFont typeface="Wingdings" panose="05000000000000000000" pitchFamily="2" charset="2"/>
+              <a:buChar char="Ø"/>
             </a:pPr>
             <a:r>
-              <a:rPr b="1" sz="1700">
+              <a:rPr sz="1700" b="1" dirty="0">
                 <a:solidFill>
                   <a:srgbClr val="F8FAFC"/>
                 </a:solidFill>
-              </a:rPr>
-              <a:t>•  ONNX Runtime: </a:t>
-            </a:r>
-            <a:r>
-              <a:rPr b="0" sz="1600">
-                <a:solidFill>
-                  <a:srgbClr val="CBD5E1"/>
-                </a:solidFill>
+                <a:latin typeface="Segoe UI" panose="020B0502040204020203" pitchFamily="34" charset="0"/>
+                <a:cs typeface="Segoe UI" panose="020B0502040204020203" pitchFamily="34" charset="0"/>
+              </a:rPr>
+              <a:t>ONNX Runtime: </a:t>
+            </a:r>
+            <a:r>
+              <a:rPr sz="1700" b="0" dirty="0">
+                <a:solidFill>
+                  <a:srgbClr val="E2E8F0"/>
+                </a:solidFill>
+                <a:latin typeface="Segoe UI" panose="020B0502040204020203" pitchFamily="34" charset="0"/>
+                <a:cs typeface="Segoe UI" panose="020B0502040204020203" pitchFamily="34" charset="0"/>
               </a:rPr>
               <a:t>Runs using the official Qualcomm QNN execution plugin on Windows.</a:t>
             </a:r>
           </a:p>
           <a:p>
-            <a:pPr>
+            <a:pPr marL="285750" indent="-285750" algn="just">
+              <a:lnSpc>
+                <a:spcPct val="150000"/>
+              </a:lnSpc>
               <a:spcAft>
-                <a:spcPts val="1600"/>
+                <a:spcPts val="1400"/>
               </a:spcAft>
+              <a:buFont typeface="Wingdings" panose="05000000000000000000" pitchFamily="2" charset="2"/>
+              <a:buChar char="Ø"/>
             </a:pPr>
             <a:r>
-              <a:rPr b="1" sz="1700">
+              <a:rPr sz="1700" b="1" dirty="0">
                 <a:solidFill>
                   <a:srgbClr val="F8FAFC"/>
                 </a:solidFill>
-              </a:rPr>
-              <a:t>•  Hexagon Driver: </a:t>
-            </a:r>
-            <a:r>
-              <a:rPr b="0" sz="1600">
-                <a:solidFill>
-                  <a:srgbClr val="CBD5E1"/>
-                </a:solidFill>
+                <a:latin typeface="Segoe UI" panose="020B0502040204020203" pitchFamily="34" charset="0"/>
+                <a:cs typeface="Segoe UI" panose="020B0502040204020203" pitchFamily="34" charset="0"/>
+              </a:rPr>
+              <a:t>Hexagon Driver: </a:t>
+            </a:r>
+            <a:r>
+              <a:rPr sz="1700" b="0" dirty="0">
+                <a:solidFill>
+                  <a:srgbClr val="E2E8F0"/>
+                </a:solidFill>
+                <a:latin typeface="Segoe UI" panose="020B0502040204020203" pitchFamily="34" charset="0"/>
+                <a:cs typeface="Segoe UI" panose="020B0502040204020203" pitchFamily="34" charset="0"/>
               </a:rPr>
               <a:t>Connects directly to Qualcomm's QnnHtp.dll driver to use the NPU hardware.</a:t>
             </a:r>
           </a:p>
           <a:p>
-            <a:pPr>
+            <a:pPr marL="285750" indent="-285750" algn="just">
+              <a:lnSpc>
+                <a:spcPct val="150000"/>
+              </a:lnSpc>
               <a:spcAft>
-                <a:spcPts val="1600"/>
+                <a:spcPts val="1400"/>
               </a:spcAft>
+              <a:buFont typeface="Wingdings" panose="05000000000000000000" pitchFamily="2" charset="2"/>
+              <a:buChar char="Ø"/>
             </a:pPr>
             <a:r>
-              <a:rPr b="1" sz="1700">
+              <a:rPr sz="1700" b="1" dirty="0">
                 <a:solidFill>
                   <a:srgbClr val="F8FAFC"/>
                 </a:solidFill>
-              </a:rPr>
-              <a:t>•  Shared Memory: </a:t>
-            </a:r>
-            <a:r>
-              <a:rPr b="0" sz="1600">
-                <a:solidFill>
-                  <a:srgbClr val="CBD5E1"/>
-                </a:solidFill>
+                <a:latin typeface="Segoe UI" panose="020B0502040204020203" pitchFamily="34" charset="0"/>
+                <a:cs typeface="Segoe UI" panose="020B0502040204020203" pitchFamily="34" charset="0"/>
+              </a:rPr>
+              <a:t>Shared Memory: </a:t>
+            </a:r>
+            <a:r>
+              <a:rPr sz="1700" b="0" dirty="0">
+                <a:solidFill>
+                  <a:srgbClr val="E2E8F0"/>
+                </a:solidFill>
+                <a:latin typeface="Segoe UI" panose="020B0502040204020203" pitchFamily="34" charset="0"/>
+                <a:cs typeface="Segoe UI" panose="020B0502040204020203" pitchFamily="34" charset="0"/>
               </a:rPr>
               <a:t>Sound features move straight into NPU memory without unnecessary data copying.</a:t>
             </a:r>
           </a:p>
           <a:p>
-            <a:pPr>
+            <a:pPr marL="285750" indent="-285750" algn="just">
+              <a:lnSpc>
+                <a:spcPct val="150000"/>
+              </a:lnSpc>
               <a:spcAft>
-                <a:spcPts val="1600"/>
+                <a:spcPts val="1400"/>
               </a:spcAft>
+              <a:buFont typeface="Wingdings" panose="05000000000000000000" pitchFamily="2" charset="2"/>
+              <a:buChar char="Ø"/>
             </a:pPr>
             <a:r>
-              <a:rPr b="1" sz="1700">
+              <a:rPr sz="1700" b="1" dirty="0">
                 <a:solidFill>
                   <a:srgbClr val="F8FAFC"/>
                 </a:solidFill>
-              </a:rPr>
-              <a:t>•  Live Threat Score: </a:t>
-            </a:r>
-            <a:r>
-              <a:rPr b="0" sz="1600">
-                <a:solidFill>
-                  <a:srgbClr val="CBD5E1"/>
-                </a:solidFill>
+                <a:latin typeface="Segoe UI" panose="020B0502040204020203" pitchFamily="34" charset="0"/>
+                <a:cs typeface="Segoe UI" panose="020B0502040204020203" pitchFamily="34" charset="0"/>
+              </a:rPr>
+              <a:t>Live Threat Score: </a:t>
+            </a:r>
+            <a:r>
+              <a:rPr sz="1700" b="0" dirty="0">
+                <a:solidFill>
+                  <a:srgbClr val="E2E8F0"/>
+                </a:solidFill>
+                <a:latin typeface="Segoe UI" panose="020B0502040204020203" pitchFamily="34" charset="0"/>
+                <a:cs typeface="Segoe UI" panose="020B0502040204020203" pitchFamily="34" charset="0"/>
               </a:rPr>
               <a:t>Updates the scam probability score every quarter of a second.</a:t>
             </a:r>
@@ -5233,7 +5584,7 @@
 </file>
 
 <file path=ppt/slides/slide7.xml><?xml version="1.0" encoding="utf-8"?>
-<p:sld xmlns:a="http://schemas.openxmlformats.org/drawingml/2006/main" xmlns:p="http://schemas.openxmlformats.org/presentationml/2006/main" xmlns:r="http://schemas.openxmlformats.org/officeDocument/2006/relationships">
+<p:sld xmlns:a="http://schemas.openxmlformats.org/drawingml/2006/main" xmlns:r="http://schemas.openxmlformats.org/officeDocument/2006/relationships" xmlns:p="http://schemas.openxmlformats.org/presentationml/2006/main">
   <p:cSld>
     <p:spTree>
       <p:nvGrpSpPr>
@@ -5241,7 +5592,14 @@
         <p:cNvGrpSpPr/>
         <p:nvPr/>
       </p:nvGrpSpPr>
-      <p:grpSpPr/>
+      <p:grpSpPr>
+        <a:xfrm>
+          <a:off x="0" y="0"/>
+          <a:ext cx="0" cy="0"/>
+          <a:chOff x="0" y="0"/>
+          <a:chExt cx="0" cy="0"/>
+        </a:xfrm>
+      </p:grpSpPr>
       <p:sp>
         <p:nvSpPr>
           <p:cNvPr id="2" name="Rectangle 1"/>
@@ -5282,6 +5640,7 @@
           <a:lstStyle/>
           <a:p>
             <a:pPr algn="ctr"/>
+            <a:endParaRPr/>
           </a:p>
         </p:txBody>
       </p:sp>
@@ -5325,6 +5684,7 @@
           <a:lstStyle/>
           <a:p>
             <a:pPr algn="ctr"/>
+            <a:endParaRPr/>
           </a:p>
         </p:txBody>
       </p:sp>
@@ -5337,7 +5697,7 @@
         <p:spPr>
           <a:xfrm>
             <a:off x="1005840" y="411480"/>
-            <a:ext cx="10424160" cy="1188720"/>
+            <a:ext cx="10424160" cy="754053"/>
           </a:xfrm>
           <a:prstGeom prst="rect">
             <a:avLst/>
@@ -5350,26 +5710,30 @@
           </a:bodyPr>
           <a:lstStyle/>
           <a:p>
-            <a:pPr>
+            <a:pPr algn="just">
               <a:defRPr sz="2800" b="1">
                 <a:solidFill>
                   <a:srgbClr val="F8FAFC"/>
                 </a:solidFill>
+                <a:latin typeface="Segoe UI Semibold"/>
               </a:defRPr>
             </a:pPr>
             <a:r>
+              <a:rPr dirty="0"/>
               <a:t>Adding the Arduino UNO Q</a:t>
             </a:r>
           </a:p>
           <a:p>
-            <a:pPr>
+            <a:pPr algn="just">
               <a:defRPr sz="1500">
                 <a:solidFill>
                   <a:srgbClr val="38BDF8"/>
                 </a:solidFill>
+                <a:latin typeface="Segoe UI"/>
               </a:defRPr>
             </a:pPr>
             <a:r>
+              <a:rPr dirty="0"/>
               <a:t>A physical warning light you cannot miss</a:t>
             </a:r>
           </a:p>
@@ -5384,7 +5748,7 @@
         <p:spPr>
           <a:xfrm>
             <a:off x="731520" y="1783080"/>
-            <a:ext cx="10698480" cy="4572000"/>
+            <a:ext cx="10698480" cy="4663440"/>
           </a:xfrm>
           <a:prstGeom prst="roundRect">
             <a:avLst/>
@@ -5417,6 +5781,7 @@
           <a:lstStyle/>
           <a:p>
             <a:pPr algn="ctr"/>
+            <a:endParaRPr/>
           </a:p>
         </p:txBody>
       </p:sp>
@@ -5429,7 +5794,7 @@
         <p:spPr>
           <a:xfrm>
             <a:off x="1051560" y="1965960"/>
-            <a:ext cx="10058400" cy="4206240"/>
+            <a:ext cx="10058400" cy="3329116"/>
           </a:xfrm>
           <a:prstGeom prst="rect">
             <a:avLst/>
@@ -5442,93 +5807,129 @@
           </a:bodyPr>
           <a:lstStyle/>
           <a:p>
-            <a:pPr>
+            <a:pPr marL="342900" indent="-342900" algn="just">
+              <a:lnSpc>
+                <a:spcPct val="150000"/>
+              </a:lnSpc>
               <a:spcAft>
-                <a:spcPts val="1600"/>
+                <a:spcPts val="1400"/>
               </a:spcAft>
+              <a:buFont typeface="Wingdings" panose="05000000000000000000" pitchFamily="2" charset="2"/>
+              <a:buChar char="Ø"/>
             </a:pPr>
             <a:r>
-              <a:rPr b="1" sz="1700">
+              <a:rPr sz="1700" b="1" dirty="0">
                 <a:solidFill>
                   <a:srgbClr val="F8FAFC"/>
                 </a:solidFill>
-              </a:rPr>
-              <a:t>•  Connected by USB: </a:t>
-            </a:r>
-            <a:r>
-              <a:rPr b="0" sz="1600">
-                <a:solidFill>
-                  <a:srgbClr val="CBD5E1"/>
-                </a:solidFill>
+                <a:latin typeface="Segoe UI" panose="020B0502040204020203" pitchFamily="34" charset="0"/>
+                <a:cs typeface="Segoe UI" panose="020B0502040204020203" pitchFamily="34" charset="0"/>
+              </a:rPr>
+              <a:t>Connected by USB: </a:t>
+            </a:r>
+            <a:r>
+              <a:rPr sz="1700" b="0" dirty="0">
+                <a:solidFill>
+                  <a:srgbClr val="E2E8F0"/>
+                </a:solidFill>
+                <a:latin typeface="Segoe UI" panose="020B0502040204020203" pitchFamily="34" charset="0"/>
+                <a:cs typeface="Segoe UI" panose="020B0502040204020203" pitchFamily="34" charset="0"/>
               </a:rPr>
               <a:t>The Snapdragon PC sends an alert byte to the Arduino board if a fake voice is detected.</a:t>
             </a:r>
           </a:p>
           <a:p>
-            <a:pPr>
+            <a:pPr marL="342900" indent="-342900" algn="just">
+              <a:lnSpc>
+                <a:spcPct val="150000"/>
+              </a:lnSpc>
               <a:spcAft>
-                <a:spcPts val="1600"/>
+                <a:spcPts val="1400"/>
               </a:spcAft>
+              <a:buFont typeface="Wingdings" panose="05000000000000000000" pitchFamily="2" charset="2"/>
+              <a:buChar char="Ø"/>
             </a:pPr>
             <a:r>
-              <a:rPr b="1" sz="1700">
+              <a:rPr sz="1700" b="1" dirty="0">
                 <a:solidFill>
                   <a:srgbClr val="F8FAFC"/>
                 </a:solidFill>
-              </a:rPr>
-              <a:t>•  Red Warning Light: </a:t>
-            </a:r>
-            <a:r>
-              <a:rPr b="0" sz="1600">
-                <a:solidFill>
-                  <a:srgbClr val="CBD5E1"/>
-                </a:solidFill>
+                <a:latin typeface="Segoe UI" panose="020B0502040204020203" pitchFamily="34" charset="0"/>
+                <a:cs typeface="Segoe UI" panose="020B0502040204020203" pitchFamily="34" charset="0"/>
+              </a:rPr>
+              <a:t>Red Warning Light: </a:t>
+            </a:r>
+            <a:r>
+              <a:rPr sz="1700" b="0" dirty="0">
+                <a:solidFill>
+                  <a:srgbClr val="E2E8F0"/>
+                </a:solidFill>
+                <a:latin typeface="Segoe UI" panose="020B0502040204020203" pitchFamily="34" charset="0"/>
+                <a:cs typeface="Segoe UI" panose="020B0502040204020203" pitchFamily="34" charset="0"/>
               </a:rPr>
               <a:t>An external red LED and warning buzzer turn on immediately to grab your attention.</a:t>
             </a:r>
           </a:p>
           <a:p>
-            <a:pPr>
+            <a:pPr marL="342900" indent="-342900" algn="just">
+              <a:lnSpc>
+                <a:spcPct val="150000"/>
+              </a:lnSpc>
               <a:spcAft>
-                <a:spcPts val="1600"/>
+                <a:spcPts val="1400"/>
               </a:spcAft>
+              <a:buFont typeface="Wingdings" panose="05000000000000000000" pitchFamily="2" charset="2"/>
+              <a:buChar char="Ø"/>
             </a:pPr>
             <a:r>
-              <a:rPr b="1" sz="1700">
+              <a:rPr sz="1700" b="1" dirty="0">
                 <a:solidFill>
                   <a:srgbClr val="F8FAFC"/>
                 </a:solidFill>
-              </a:rPr>
-              <a:t>•  Tamper-Proof Alert: </a:t>
-            </a:r>
-            <a:r>
-              <a:rPr b="0" sz="1600">
-                <a:solidFill>
-                  <a:srgbClr val="CBD5E1"/>
-                </a:solidFill>
+                <a:latin typeface="Segoe UI" panose="020B0502040204020203" pitchFamily="34" charset="0"/>
+                <a:cs typeface="Segoe UI" panose="020B0502040204020203" pitchFamily="34" charset="0"/>
+              </a:rPr>
+              <a:t>Tamper-Proof Alert: </a:t>
+            </a:r>
+            <a:r>
+              <a:rPr sz="1700" b="0" dirty="0">
+                <a:solidFill>
+                  <a:srgbClr val="E2E8F0"/>
+                </a:solidFill>
+                <a:latin typeface="Segoe UI" panose="020B0502040204020203" pitchFamily="34" charset="0"/>
+                <a:cs typeface="Segoe UI" panose="020B0502040204020203" pitchFamily="34" charset="0"/>
               </a:rPr>
               <a:t>Even if a scammer full-screens a window or covers your display, the physical light stays visible.</a:t>
             </a:r>
           </a:p>
           <a:p>
-            <a:pPr>
+            <a:pPr marL="342900" indent="-342900" algn="just">
+              <a:lnSpc>
+                <a:spcPct val="150000"/>
+              </a:lnSpc>
               <a:spcAft>
-                <a:spcPts val="1600"/>
+                <a:spcPts val="1400"/>
               </a:spcAft>
+              <a:buFont typeface="Wingdings" panose="05000000000000000000" pitchFamily="2" charset="2"/>
+              <a:buChar char="Ø"/>
             </a:pPr>
             <a:r>
-              <a:rPr b="1" sz="1700">
+              <a:rPr sz="1700" b="1" dirty="0">
                 <a:solidFill>
                   <a:srgbClr val="F8FAFC"/>
                 </a:solidFill>
-              </a:rPr>
-              <a:t>•  Safe Mode: </a:t>
-            </a:r>
-            <a:r>
-              <a:rPr b="0" sz="1600">
-                <a:solidFill>
-                  <a:srgbClr val="CBD5E1"/>
-                </a:solidFill>
+                <a:latin typeface="Segoe UI" panose="020B0502040204020203" pitchFamily="34" charset="0"/>
+                <a:cs typeface="Segoe UI" panose="020B0502040204020203" pitchFamily="34" charset="0"/>
+              </a:rPr>
+              <a:t>Safe Mode: </a:t>
+            </a:r>
+            <a:r>
+              <a:rPr sz="1700" b="0" dirty="0">
+                <a:solidFill>
+                  <a:srgbClr val="E2E8F0"/>
+                </a:solidFill>
+                <a:latin typeface="Segoe UI" panose="020B0502040204020203" pitchFamily="34" charset="0"/>
+                <a:cs typeface="Segoe UI" panose="020B0502040204020203" pitchFamily="34" charset="0"/>
               </a:rPr>
               <a:t>Shows a steady green light when normal human speech is verified.</a:t>
             </a:r>
@@ -5544,7 +5945,7 @@
 </file>
 
 <file path=ppt/slides/slide8.xml><?xml version="1.0" encoding="utf-8"?>
-<p:sld xmlns:a="http://schemas.openxmlformats.org/drawingml/2006/main" xmlns:p="http://schemas.openxmlformats.org/presentationml/2006/main" xmlns:r="http://schemas.openxmlformats.org/officeDocument/2006/relationships">
+<p:sld xmlns:a="http://schemas.openxmlformats.org/drawingml/2006/main" xmlns:r="http://schemas.openxmlformats.org/officeDocument/2006/relationships" xmlns:p="http://schemas.openxmlformats.org/presentationml/2006/main">
   <p:cSld>
     <p:spTree>
       <p:nvGrpSpPr>
@@ -5552,7 +5953,14 @@
         <p:cNvGrpSpPr/>
         <p:nvPr/>
       </p:nvGrpSpPr>
-      <p:grpSpPr/>
+      <p:grpSpPr>
+        <a:xfrm>
+          <a:off x="0" y="0"/>
+          <a:ext cx="0" cy="0"/>
+          <a:chOff x="0" y="0"/>
+          <a:chExt cx="0" cy="0"/>
+        </a:xfrm>
+      </p:grpSpPr>
       <p:sp>
         <p:nvSpPr>
           <p:cNvPr id="2" name="Rectangle 1"/>
@@ -5593,6 +6001,7 @@
           <a:lstStyle/>
           <a:p>
             <a:pPr algn="ctr"/>
+            <a:endParaRPr/>
           </a:p>
         </p:txBody>
       </p:sp>
@@ -5636,6 +6045,7 @@
           <a:lstStyle/>
           <a:p>
             <a:pPr algn="ctr"/>
+            <a:endParaRPr/>
           </a:p>
         </p:txBody>
       </p:sp>
@@ -5666,6 +6076,7 @@
                 <a:solidFill>
                   <a:srgbClr val="F8FAFC"/>
                 </a:solidFill>
+                <a:latin typeface="Segoe UI Semibold"/>
               </a:defRPr>
             </a:pPr>
             <a:r>
@@ -5678,6 +6089,7 @@
                 <a:solidFill>
                   <a:srgbClr val="38BDF8"/>
                 </a:solidFill>
+                <a:latin typeface="Segoe UI"/>
               </a:defRPr>
             </a:pPr>
             <a:r>
@@ -5695,7 +6107,7 @@
         <p:spPr>
           <a:xfrm>
             <a:off x="731520" y="1783080"/>
-            <a:ext cx="10698480" cy="4572000"/>
+            <a:ext cx="10698480" cy="4663440"/>
           </a:xfrm>
           <a:prstGeom prst="roundRect">
             <a:avLst/>
@@ -5728,6 +6140,7 @@
           <a:lstStyle/>
           <a:p>
             <a:pPr algn="ctr"/>
+            <a:endParaRPr/>
           </a:p>
         </p:txBody>
       </p:sp>
@@ -5740,7 +6153,7 @@
         <p:spPr>
           <a:xfrm>
             <a:off x="1051560" y="1965960"/>
-            <a:ext cx="10058400" cy="4206240"/>
+            <a:ext cx="10058400" cy="2151871"/>
           </a:xfrm>
           <a:prstGeom prst="rect">
             <a:avLst/>
@@ -5753,93 +6166,129 @@
           </a:bodyPr>
           <a:lstStyle/>
           <a:p>
-            <a:pPr>
+            <a:pPr marL="285750" indent="-285750" algn="just">
+              <a:lnSpc>
+                <a:spcPct val="150000"/>
+              </a:lnSpc>
               <a:spcAft>
-                <a:spcPts val="1600"/>
+                <a:spcPts val="1400"/>
               </a:spcAft>
+              <a:buFont typeface="Wingdings" panose="05000000000000000000" pitchFamily="2" charset="2"/>
+              <a:buChar char="Ø"/>
             </a:pPr>
             <a:r>
-              <a:rPr b="1" sz="1700">
+              <a:rPr sz="1700" b="1" dirty="0">
                 <a:solidFill>
                   <a:srgbClr val="F8FAFC"/>
                 </a:solidFill>
-              </a:rPr>
-              <a:t>•  System Tray App: </a:t>
-            </a:r>
-            <a:r>
-              <a:rPr b="0" sz="1600">
-                <a:solidFill>
-                  <a:srgbClr val="CBD5E1"/>
-                </a:solidFill>
+                <a:latin typeface="Segoe UI" panose="020B0502040204020203" pitchFamily="34" charset="0"/>
+                <a:cs typeface="Segoe UI" panose="020B0502040204020203" pitchFamily="34" charset="0"/>
+              </a:rPr>
+              <a:t>System Tray App: </a:t>
+            </a:r>
+            <a:r>
+              <a:rPr sz="1700" b="0" dirty="0">
+                <a:solidFill>
+                  <a:srgbClr val="E2E8F0"/>
+                </a:solidFill>
+                <a:latin typeface="Segoe UI" panose="020B0502040204020203" pitchFamily="34" charset="0"/>
+                <a:cs typeface="Segoe UI" panose="020B0502040204020203" pitchFamily="34" charset="0"/>
               </a:rPr>
               <a:t>Sits quietly in the Windows taskbar just like an antivirus tool.</a:t>
             </a:r>
           </a:p>
           <a:p>
-            <a:pPr>
+            <a:pPr marL="285750" indent="-285750" algn="just">
+              <a:lnSpc>
+                <a:spcPct val="150000"/>
+              </a:lnSpc>
               <a:spcAft>
-                <a:spcPts val="1600"/>
+                <a:spcPts val="1400"/>
               </a:spcAft>
+              <a:buFont typeface="Wingdings" panose="05000000000000000000" pitchFamily="2" charset="2"/>
+              <a:buChar char="Ø"/>
             </a:pPr>
             <a:r>
-              <a:rPr b="1" sz="1700">
+              <a:rPr sz="1700" b="1" dirty="0">
                 <a:solidFill>
                   <a:srgbClr val="F8FAFC"/>
                 </a:solidFill>
-              </a:rPr>
-              <a:t>•  Very Low Memory: </a:t>
-            </a:r>
-            <a:r>
-              <a:rPr b="0" sz="1600">
-                <a:solidFill>
-                  <a:srgbClr val="CBD5E1"/>
-                </a:solidFill>
+                <a:latin typeface="Segoe UI" panose="020B0502040204020203" pitchFamily="34" charset="0"/>
+                <a:cs typeface="Segoe UI" panose="020B0502040204020203" pitchFamily="34" charset="0"/>
+              </a:rPr>
+              <a:t>Very Low Memory: </a:t>
+            </a:r>
+            <a:r>
+              <a:rPr sz="1700" b="0" dirty="0">
+                <a:solidFill>
+                  <a:srgbClr val="E2E8F0"/>
+                </a:solidFill>
+                <a:latin typeface="Segoe UI" panose="020B0502040204020203" pitchFamily="34" charset="0"/>
+                <a:cs typeface="Segoe UI" panose="020B0502040204020203" pitchFamily="34" charset="0"/>
               </a:rPr>
               <a:t>Uses under 120 MB of RAM and less than 3% CPU power.</a:t>
             </a:r>
           </a:p>
           <a:p>
-            <a:pPr>
+            <a:pPr marL="285750" indent="-285750" algn="just">
+              <a:lnSpc>
+                <a:spcPct val="150000"/>
+              </a:lnSpc>
               <a:spcAft>
-                <a:spcPts val="1600"/>
+                <a:spcPts val="1400"/>
               </a:spcAft>
+              <a:buFont typeface="Wingdings" panose="05000000000000000000" pitchFamily="2" charset="2"/>
+              <a:buChar char="Ø"/>
             </a:pPr>
             <a:r>
-              <a:rPr b="1" sz="1700">
+              <a:rPr sz="1700" b="1" dirty="0">
                 <a:solidFill>
                   <a:srgbClr val="F8FAFC"/>
                 </a:solidFill>
-              </a:rPr>
-              <a:t>•  No Complex Setup: </a:t>
-            </a:r>
-            <a:r>
-              <a:rPr b="0" sz="1600">
-                <a:solidFill>
-                  <a:srgbClr val="CBD5E1"/>
-                </a:solidFill>
+                <a:latin typeface="Segoe UI" panose="020B0502040204020203" pitchFamily="34" charset="0"/>
+                <a:cs typeface="Segoe UI" panose="020B0502040204020203" pitchFamily="34" charset="0"/>
+              </a:rPr>
+              <a:t>No Complex Setup: </a:t>
+            </a:r>
+            <a:r>
+              <a:rPr sz="1700" b="0" dirty="0">
+                <a:solidFill>
+                  <a:srgbClr val="E2E8F0"/>
+                </a:solidFill>
+                <a:latin typeface="Segoe UI" panose="020B0502040204020203" pitchFamily="34" charset="0"/>
+                <a:cs typeface="Segoe UI" panose="020B0502040204020203" pitchFamily="34" charset="0"/>
               </a:rPr>
               <a:t>Automatically listens to your default call audio without changing app settings.</a:t>
             </a:r>
           </a:p>
           <a:p>
-            <a:pPr>
+            <a:pPr marL="285750" indent="-285750" algn="just">
+              <a:lnSpc>
+                <a:spcPct val="150000"/>
+              </a:lnSpc>
               <a:spcAft>
-                <a:spcPts val="1600"/>
+                <a:spcPts val="1400"/>
               </a:spcAft>
+              <a:buFont typeface="Wingdings" panose="05000000000000000000" pitchFamily="2" charset="2"/>
+              <a:buChar char="Ø"/>
             </a:pPr>
             <a:r>
-              <a:rPr b="1" sz="1700">
+              <a:rPr sz="1700" b="1" dirty="0">
                 <a:solidFill>
                   <a:srgbClr val="F8FAFC"/>
                 </a:solidFill>
-              </a:rPr>
-              <a:t>•  Works Offline: </a:t>
-            </a:r>
-            <a:r>
-              <a:rPr b="0" sz="1600">
-                <a:solidFill>
-                  <a:srgbClr val="CBD5E1"/>
-                </a:solidFill>
+                <a:latin typeface="Segoe UI" panose="020B0502040204020203" pitchFamily="34" charset="0"/>
+                <a:cs typeface="Segoe UI" panose="020B0502040204020203" pitchFamily="34" charset="0"/>
+              </a:rPr>
+              <a:t>Works Offline: </a:t>
+            </a:r>
+            <a:r>
+              <a:rPr sz="1700" b="0" dirty="0">
+                <a:solidFill>
+                  <a:srgbClr val="E2E8F0"/>
+                </a:solidFill>
+                <a:latin typeface="Segoe UI" panose="020B0502040204020203" pitchFamily="34" charset="0"/>
+                <a:cs typeface="Segoe UI" panose="020B0502040204020203" pitchFamily="34" charset="0"/>
               </a:rPr>
               <a:t>Tested and fully working with Wi-Fi and Bluetooth turned off (Airplane Mode).</a:t>
             </a:r>
@@ -5855,7 +6304,7 @@
 </file>
 
 <file path=ppt/slides/slide9.xml><?xml version="1.0" encoding="utf-8"?>
-<p:sld xmlns:a="http://schemas.openxmlformats.org/drawingml/2006/main" xmlns:p="http://schemas.openxmlformats.org/presentationml/2006/main" xmlns:r="http://schemas.openxmlformats.org/officeDocument/2006/relationships">
+<p:sld xmlns:a="http://schemas.openxmlformats.org/drawingml/2006/main" xmlns:r="http://schemas.openxmlformats.org/officeDocument/2006/relationships" xmlns:p="http://schemas.openxmlformats.org/presentationml/2006/main">
   <p:cSld>
     <p:spTree>
       <p:nvGrpSpPr>
@@ -5863,7 +6312,14 @@
         <p:cNvGrpSpPr/>
         <p:nvPr/>
       </p:nvGrpSpPr>
-      <p:grpSpPr/>
+      <p:grpSpPr>
+        <a:xfrm>
+          <a:off x="0" y="0"/>
+          <a:ext cx="0" cy="0"/>
+          <a:chOff x="0" y="0"/>
+          <a:chExt cx="0" cy="0"/>
+        </a:xfrm>
+      </p:grpSpPr>
       <p:sp>
         <p:nvSpPr>
           <p:cNvPr id="2" name="Rectangle 1"/>
@@ -5904,6 +6360,7 @@
           <a:lstStyle/>
           <a:p>
             <a:pPr algn="ctr"/>
+            <a:endParaRPr/>
           </a:p>
         </p:txBody>
       </p:sp>
@@ -5947,6 +6404,7 @@
           <a:lstStyle/>
           <a:p>
             <a:pPr algn="ctr"/>
+            <a:endParaRPr/>
           </a:p>
         </p:txBody>
       </p:sp>
@@ -5959,7 +6417,7 @@
         <p:spPr>
           <a:xfrm>
             <a:off x="1005840" y="411480"/>
-            <a:ext cx="10424160" cy="1188720"/>
+            <a:ext cx="10424160" cy="754053"/>
           </a:xfrm>
           <a:prstGeom prst="rect">
             <a:avLst/>
@@ -5972,26 +6430,30 @@
           </a:bodyPr>
           <a:lstStyle/>
           <a:p>
-            <a:pPr>
+            <a:pPr algn="just">
               <a:defRPr sz="2800" b="1">
                 <a:solidFill>
                   <a:srgbClr val="F8FAFC"/>
                 </a:solidFill>
+                <a:latin typeface="Segoe UI Semibold"/>
               </a:defRPr>
             </a:pPr>
             <a:r>
+              <a:rPr dirty="0"/>
               <a:t>Meeting Competition Goals</a:t>
             </a:r>
           </a:p>
           <a:p>
-            <a:pPr>
+            <a:pPr algn="just">
               <a:defRPr sz="1500">
                 <a:solidFill>
                   <a:srgbClr val="38BDF8"/>
                 </a:solidFill>
+                <a:latin typeface="Segoe UI"/>
               </a:defRPr>
             </a:pPr>
             <a:r>
+              <a:rPr dirty="0"/>
               <a:t>Built directly to address Qualcomm's evaluation criteria</a:t>
             </a:r>
           </a:p>
@@ -6006,7 +6468,7 @@
         <p:spPr>
           <a:xfrm>
             <a:off x="731520" y="1783080"/>
-            <a:ext cx="10698480" cy="4572000"/>
+            <a:ext cx="10698480" cy="4663440"/>
           </a:xfrm>
           <a:prstGeom prst="roundRect">
             <a:avLst/>
@@ -6039,6 +6501,7 @@
           <a:lstStyle/>
           <a:p>
             <a:pPr algn="ctr"/>
+            <a:endParaRPr/>
           </a:p>
         </p:txBody>
       </p:sp>
@@ -6051,7 +6514,7 @@
         <p:spPr>
           <a:xfrm>
             <a:off x="1051560" y="1965960"/>
-            <a:ext cx="10058400" cy="4206240"/>
+            <a:ext cx="10058400" cy="2936701"/>
           </a:xfrm>
           <a:prstGeom prst="rect">
             <a:avLst/>
@@ -6064,93 +6527,129 @@
           </a:bodyPr>
           <a:lstStyle/>
           <a:p>
-            <a:pPr>
+            <a:pPr marL="285750" indent="-285750" algn="just">
+              <a:lnSpc>
+                <a:spcPct val="150000"/>
+              </a:lnSpc>
               <a:spcAft>
-                <a:spcPts val="1600"/>
+                <a:spcPts val="1400"/>
               </a:spcAft>
+              <a:buFont typeface="Wingdings" panose="05000000000000000000" pitchFamily="2" charset="2"/>
+              <a:buChar char="Ø"/>
             </a:pPr>
             <a:r>
-              <a:rPr b="1" sz="1700">
+              <a:rPr sz="1700" b="1" dirty="0">
                 <a:solidFill>
                   <a:srgbClr val="F8FAFC"/>
                 </a:solidFill>
-              </a:rPr>
-              <a:t>•  Technical Implementation: </a:t>
-            </a:r>
-            <a:r>
-              <a:rPr b="0" sz="1600">
-                <a:solidFill>
-                  <a:srgbClr val="CBD5E1"/>
-                </a:solidFill>
+                <a:latin typeface="Segoe UI" panose="020B0502040204020203" pitchFamily="34" charset="0"/>
+                <a:cs typeface="Segoe UI" panose="020B0502040204020203" pitchFamily="34" charset="0"/>
+              </a:rPr>
+              <a:t>Technical Implementation: </a:t>
+            </a:r>
+            <a:r>
+              <a:rPr sz="1700" b="0" dirty="0">
+                <a:solidFill>
+                  <a:srgbClr val="E2E8F0"/>
+                </a:solidFill>
+                <a:latin typeface="Segoe UI" panose="020B0502040204020203" pitchFamily="34" charset="0"/>
+                <a:cs typeface="Segoe UI" panose="020B0502040204020203" pitchFamily="34" charset="0"/>
               </a:rPr>
               <a:t>Real audio signal processing, Qualcomm AI Hub model optimization, and Hexagon NPU offload.</a:t>
             </a:r>
           </a:p>
           <a:p>
-            <a:pPr>
+            <a:pPr marL="285750" indent="-285750" algn="just">
+              <a:lnSpc>
+                <a:spcPct val="150000"/>
+              </a:lnSpc>
               <a:spcAft>
-                <a:spcPts val="1600"/>
+                <a:spcPts val="1400"/>
               </a:spcAft>
+              <a:buFont typeface="Wingdings" panose="05000000000000000000" pitchFamily="2" charset="2"/>
+              <a:buChar char="Ø"/>
             </a:pPr>
             <a:r>
-              <a:rPr b="1" sz="1700">
+              <a:rPr sz="1700" b="1" dirty="0">
                 <a:solidFill>
                   <a:srgbClr val="F8FAFC"/>
                 </a:solidFill>
-              </a:rPr>
-              <a:t>•  Application &amp; Innovation: </a:t>
-            </a:r>
-            <a:r>
-              <a:rPr b="0" sz="1600">
-                <a:solidFill>
-                  <a:srgbClr val="CBD5E1"/>
-                </a:solidFill>
+                <a:latin typeface="Segoe UI" panose="020B0502040204020203" pitchFamily="34" charset="0"/>
+                <a:cs typeface="Segoe UI" panose="020B0502040204020203" pitchFamily="34" charset="0"/>
+              </a:rPr>
+              <a:t>Application &amp; Innovation: </a:t>
+            </a:r>
+            <a:r>
+              <a:rPr sz="1700" b="0" dirty="0">
+                <a:solidFill>
+                  <a:srgbClr val="E2E8F0"/>
+                </a:solidFill>
+                <a:latin typeface="Segoe UI" panose="020B0502040204020203" pitchFamily="34" charset="0"/>
+                <a:cs typeface="Segoe UI" panose="020B0502040204020203" pitchFamily="34" charset="0"/>
               </a:rPr>
               <a:t>Solves real-world AI voice scams in India while keeping user data private.</a:t>
             </a:r>
           </a:p>
           <a:p>
-            <a:pPr>
+            <a:pPr marL="285750" indent="-285750" algn="just">
+              <a:lnSpc>
+                <a:spcPct val="150000"/>
+              </a:lnSpc>
               <a:spcAft>
-                <a:spcPts val="1600"/>
+                <a:spcPts val="1400"/>
               </a:spcAft>
+              <a:buFont typeface="Wingdings" panose="05000000000000000000" pitchFamily="2" charset="2"/>
+              <a:buChar char="Ø"/>
             </a:pPr>
             <a:r>
-              <a:rPr b="1" sz="1700">
+              <a:rPr sz="1700" b="1" dirty="0">
                 <a:solidFill>
                   <a:srgbClr val="F8FAFC"/>
                 </a:solidFill>
-              </a:rPr>
-              <a:t>•  Deployment on Snapdragon: </a:t>
-            </a:r>
-            <a:r>
-              <a:rPr b="0" sz="1600">
-                <a:solidFill>
-                  <a:srgbClr val="CBD5E1"/>
-                </a:solidFill>
+                <a:latin typeface="Segoe UI" panose="020B0502040204020203" pitchFamily="34" charset="0"/>
+                <a:cs typeface="Segoe UI" panose="020B0502040204020203" pitchFamily="34" charset="0"/>
+              </a:rPr>
+              <a:t>Deployment on Snapdragon: </a:t>
+            </a:r>
+            <a:r>
+              <a:rPr sz="1700" b="0" dirty="0">
+                <a:solidFill>
+                  <a:srgbClr val="E2E8F0"/>
+                </a:solidFill>
+                <a:latin typeface="Segoe UI" panose="020B0502040204020203" pitchFamily="34" charset="0"/>
+                <a:cs typeface="Segoe UI" panose="020B0502040204020203" pitchFamily="34" charset="0"/>
               </a:rPr>
               <a:t>Designed specifically for Windows on Snapdragon HP PCs with low power draw.</a:t>
             </a:r>
           </a:p>
           <a:p>
-            <a:pPr>
+            <a:pPr marL="285750" indent="-285750" algn="just">
+              <a:lnSpc>
+                <a:spcPct val="150000"/>
+              </a:lnSpc>
               <a:spcAft>
-                <a:spcPts val="1600"/>
+                <a:spcPts val="1400"/>
               </a:spcAft>
+              <a:buFont typeface="Wingdings" panose="05000000000000000000" pitchFamily="2" charset="2"/>
+              <a:buChar char="Ø"/>
             </a:pPr>
             <a:r>
-              <a:rPr b="1" sz="1700">
+              <a:rPr sz="1700" b="1" dirty="0">
                 <a:solidFill>
                   <a:srgbClr val="F8FAFC"/>
                 </a:solidFill>
-              </a:rPr>
-              <a:t>•  Clear Documentation: </a:t>
-            </a:r>
-            <a:r>
-              <a:rPr b="0" sz="1600">
-                <a:solidFill>
-                  <a:srgbClr val="CBD5E1"/>
-                </a:solidFill>
+                <a:latin typeface="Segoe UI" panose="020B0502040204020203" pitchFamily="34" charset="0"/>
+                <a:cs typeface="Segoe UI" panose="020B0502040204020203" pitchFamily="34" charset="0"/>
+              </a:rPr>
+              <a:t>Clear Documentation: </a:t>
+            </a:r>
+            <a:r>
+              <a:rPr sz="1700" b="0" dirty="0">
+                <a:solidFill>
+                  <a:srgbClr val="E2E8F0"/>
+                </a:solidFill>
+                <a:latin typeface="Segoe UI" panose="020B0502040204020203" pitchFamily="34" charset="0"/>
+                <a:cs typeface="Segoe UI" panose="020B0502040204020203" pitchFamily="34" charset="0"/>
               </a:rPr>
               <a:t>Backed by full code, clean setup instructions, and working scripts on GitHub.</a:t>
             </a:r>

</xml_diff>

<commit_message>
Update pitch presentation (PPTX and PDF)
</commit_message>
<xml_diff>
--- a/submission_assets/VoiceArmor_Edge_Pitch.pptx
+++ b/submission_assets/VoiceArmor_Edge_Pitch.pptx
@@ -3894,7 +3894,7 @@
         <p:spPr>
           <a:xfrm>
             <a:off x="1005840" y="411480"/>
-            <a:ext cx="10424160" cy="1188720"/>
+            <a:ext cx="10424160" cy="754053"/>
           </a:xfrm>
           <a:prstGeom prst="rect">
             <a:avLst/>
@@ -3907,7 +3907,7 @@
           </a:bodyPr>
           <a:lstStyle/>
           <a:p>
-            <a:pPr>
+            <a:pPr algn="just">
               <a:defRPr sz="2800" b="1">
                 <a:solidFill>
                   <a:srgbClr val="F8FAFC"/>
@@ -3916,11 +3916,12 @@
               </a:defRPr>
             </a:pPr>
             <a:r>
+              <a:rPr dirty="0"/>
               <a:t>The Problem: AI Voice Scams &amp; Impersonation</a:t>
             </a:r>
           </a:p>
           <a:p>
-            <a:pPr>
+            <a:pPr algn="just">
               <a:defRPr sz="1500">
                 <a:solidFill>
                   <a:srgbClr val="38BDF8"/>
@@ -3929,6 +3930,7 @@
               </a:defRPr>
             </a:pPr>
             <a:r>
+              <a:rPr dirty="0"/>
               <a:t>Scammers clone voices in seconds to trick people on live calls</a:t>
             </a:r>
           </a:p>
@@ -6058,7 +6060,7 @@
         <p:spPr>
           <a:xfrm>
             <a:off x="1005840" y="411480"/>
-            <a:ext cx="10424160" cy="1188720"/>
+            <a:ext cx="10424160" cy="754053"/>
           </a:xfrm>
           <a:prstGeom prst="rect">
             <a:avLst/>
@@ -6071,7 +6073,7 @@
           </a:bodyPr>
           <a:lstStyle/>
           <a:p>
-            <a:pPr>
+            <a:pPr algn="just">
               <a:defRPr sz="2800" b="1">
                 <a:solidFill>
                   <a:srgbClr val="F8FAFC"/>
@@ -6080,11 +6082,17 @@
               </a:defRPr>
             </a:pPr>
             <a:r>
-              <a:t>Running on the HP OmniBook</a:t>
-            </a:r>
-          </a:p>
-          <a:p>
-            <a:pPr>
+              <a:rPr dirty="0"/>
+              <a:t>Running on the HP </a:t>
+            </a:r>
+            <a:r>
+              <a:rPr dirty="0" err="1"/>
+              <a:t>OmniBook</a:t>
+            </a:r>
+            <a:endParaRPr dirty="0"/>
+          </a:p>
+          <a:p>
+            <a:pPr algn="just">
               <a:defRPr sz="1500">
                 <a:solidFill>
                   <a:srgbClr val="38BDF8"/>
@@ -6093,6 +6101,7 @@
               </a:defRPr>
             </a:pPr>
             <a:r>
+              <a:rPr dirty="0"/>
               <a:t>Quiet, lightweight protection in the background</a:t>
             </a:r>
           </a:p>

</xml_diff>